<commit_message>
feat: add premium animated landing page
</commit_message>
<xml_diff>
--- a/Intain-Verify-Pitch.pptx
+++ b/Intain-Verify-Pitch.pptx
@@ -4,6 +4,9 @@
   <p:sldMasterIdLst>
     <p:sldMasterId id="2147483648" r:id="rId1"/>
   </p:sldMasterIdLst>
+  <p:notesMasterIdLst>
+    <p:notesMasterId r:id="rId15"/>
+  </p:notesMasterIdLst>
   <p:sldIdLst>
     <p:sldId id="256" r:id="rId2"/>
     <p:sldId id="257" r:id="rId3"/>
@@ -19,9 +22,6 @@
     <p:sldId id="267" r:id="rId13"/>
     <p:sldId id="268" r:id="rId14"/>
   </p:sldIdLst>
-  <p:notesMasterIdLst>
-    <p:notesMasterId r:id="rId15"/>
-  </p:notesMasterIdLst>
   <p:sldSz cx="12192000" cy="6858000"/>
   <p:notesSz cx="6858000" cy="12192000"/>
   <p:defaultTextStyle>
@@ -116,6 +116,11 @@
       </a:defRPr>
     </a:lvl9pPr>
   </p:defaultTextStyle>
+  <p:extLst>
+    <p:ext uri="{EFAFB233-063F-42B5-8137-9DF3F51BA10A}">
+      <p15:sldGuideLst xmlns:p15="http://schemas.microsoft.com/office/powerpoint/2012/main"/>
+    </p:ext>
+  </p:extLst>
 </p:presentation>
 </file>
 
@@ -141,234 +146,10 @@
           <a:chExt cx="0" cy="0"/>
         </a:xfrm>
       </p:grpSpPr>
-      <p:sp>
-        <p:nvSpPr>
-          <p:cNvPr id="2" name="Header Placeholder 1"/>
-          <p:cNvSpPr>
-            <a:spLocks noGrp="1"/>
-          </p:cNvSpPr>
-          <p:nvPr>
-            <p:ph type="hdr" sz="quarter"/>
-          </p:nvPr>
-        </p:nvSpPr>
-        <p:spPr>
-          <a:xfrm>
-            <a:off x="0" y="0"/>
-            <a:ext cx="2971800" cy="458788"/>
-          </a:xfrm>
-          <a:prstGeom prst="rect">
-            <a:avLst/>
-          </a:prstGeom>
-        </p:spPr>
-        <p:txBody>
-          <a:bodyPr vert="horz" lIns="91440" tIns="45720" rIns="91440" bIns="45720" rtlCol="0"/>
-          <a:lstStyle>
-            <a:lvl1pPr algn="l">
-              <a:defRPr sz="1200"/>
-            </a:lvl1pPr>
-          </a:lstStyle>
-          <a:p>
-            <a:endParaRPr lang="en-US"/>
-          </a:p>
-        </p:txBody>
-      </p:sp>
-      <p:sp>
-        <p:nvSpPr>
-          <p:cNvPr id="3" name="Date Placeholder 2"/>
-          <p:cNvSpPr>
-            <a:spLocks noGrp="1"/>
-          </p:cNvSpPr>
-          <p:nvPr>
-            <p:ph type="dt" idx="1"/>
-          </p:nvPr>
-        </p:nvSpPr>
-        <p:spPr>
-          <a:xfrm>
-            <a:off x="3884613" y="0"/>
-            <a:ext cx="2971800" cy="458788"/>
-          </a:xfrm>
-          <a:prstGeom prst="rect">
-            <a:avLst/>
-          </a:prstGeom>
-        </p:spPr>
-        <p:txBody>
-          <a:bodyPr vert="horz" lIns="91440" tIns="45720" rIns="91440" bIns="45720" rtlCol="0"/>
-          <a:lstStyle>
-            <a:lvl1pPr algn="r">
-              <a:defRPr sz="1200"/>
-            </a:lvl1pPr>
-          </a:lstStyle>
-          <a:p>
-            <a:fld id="{5282F153-3F37-0F45-9E97-73ACFA13230C}" type="datetimeFigureOut">
-              <a:rPr lang="en-US"/>
-              <a:t>7/23/19</a:t>
-            </a:fld>
-            <a:endParaRPr lang="en-US"/>
-          </a:p>
-        </p:txBody>
-      </p:sp>
-      <p:sp>
-        <p:nvSpPr>
-          <p:cNvPr id="4" name="Slide Image Placeholder 3"/>
-          <p:cNvSpPr>
-            <a:spLocks noGrp="1" noRot="1" noChangeAspect="1"/>
-          </p:cNvSpPr>
-          <p:nvPr>
-            <p:ph type="sldImg" idx="2"/>
-          </p:nvPr>
-        </p:nvSpPr>
-        <p:spPr>
-          <a:xfrm>
-            <a:off x="685800" y="1143000"/>
-            <a:ext cx="5486400" cy="3086100"/>
-          </a:xfrm>
-          <a:prstGeom prst="rect">
-            <a:avLst/>
-          </a:prstGeom>
-          <a:noFill/>
-          <a:ln w="12700">
-            <a:solidFill>
-              <a:prstClr val="black"/>
-            </a:solidFill>
-          </a:ln>
-        </p:spPr>
-        <p:txBody>
-          <a:bodyPr vert="horz" lIns="91440" tIns="45720" rIns="91440" bIns="45720" rtlCol="0" anchor="ctr"/>
-          <a:lstStyle/>
-          <a:p>
-            <a:endParaRPr lang="en-US"/>
-          </a:p>
-        </p:txBody>
-      </p:sp>
-      <p:sp>
-        <p:nvSpPr>
-          <p:cNvPr id="5" name="Notes Placeholder 4"/>
-          <p:cNvSpPr>
-            <a:spLocks noGrp="1"/>
-          </p:cNvSpPr>
-          <p:nvPr>
-            <p:ph type="body" sz="quarter" idx="3"/>
-          </p:nvPr>
-        </p:nvSpPr>
-        <p:spPr>
-          <a:xfrm>
-            <a:off x="685800" y="4400550"/>
-            <a:ext cx="5486400" cy="3600450"/>
-          </a:xfrm>
-          <a:prstGeom prst="rect">
-            <a:avLst/>
-          </a:prstGeom>
-        </p:spPr>
-        <p:txBody>
-          <a:bodyPr vert="horz" lIns="91440" tIns="45720" rIns="91440" bIns="45720" rtlCol="0"/>
-          <a:lstStyle/>
-          <a:p>
-            <a:pPr lvl="0"/>
-            <a:r>
-              <a:rPr lang="en-US"/>
-              <a:t>Click to edit Master text styles</a:t>
-            </a:r>
-          </a:p>
-          <a:p>
-            <a:pPr lvl="1"/>
-            <a:r>
-              <a:rPr lang="en-US"/>
-              <a:t>Second level</a:t>
-            </a:r>
-          </a:p>
-          <a:p>
-            <a:pPr lvl="2"/>
-            <a:r>
-              <a:rPr lang="en-US"/>
-              <a:t>Third level</a:t>
-            </a:r>
-          </a:p>
-          <a:p>
-            <a:pPr lvl="3"/>
-            <a:r>
-              <a:rPr lang="en-US"/>
-              <a:t>Fourth level</a:t>
-            </a:r>
-          </a:p>
-          <a:p>
-            <a:pPr lvl="4"/>
-            <a:r>
-              <a:rPr lang="en-US"/>
-              <a:t>Fifth level</a:t>
-            </a:r>
-          </a:p>
-        </p:txBody>
-      </p:sp>
-      <p:sp>
-        <p:nvSpPr>
-          <p:cNvPr id="6" name="Footer Placeholder 5"/>
-          <p:cNvSpPr>
-            <a:spLocks noGrp="1"/>
-          </p:cNvSpPr>
-          <p:nvPr>
-            <p:ph type="ftr" sz="quarter" idx="4"/>
-          </p:nvPr>
-        </p:nvSpPr>
-        <p:spPr>
-          <a:xfrm>
-            <a:off x="0" y="8685213"/>
-            <a:ext cx="2971800" cy="458787"/>
-          </a:xfrm>
-          <a:prstGeom prst="rect">
-            <a:avLst/>
-          </a:prstGeom>
-        </p:spPr>
-        <p:txBody>
-          <a:bodyPr vert="horz" lIns="91440" tIns="45720" rIns="91440" bIns="45720" rtlCol="0" anchor="b"/>
-          <a:lstStyle>
-            <a:lvl1pPr algn="l">
-              <a:defRPr sz="1200"/>
-            </a:lvl1pPr>
-          </a:lstStyle>
-          <a:p>
-            <a:endParaRPr lang="en-US"/>
-          </a:p>
-        </p:txBody>
-      </p:sp>
-      <p:sp>
-        <p:nvSpPr>
-          <p:cNvPr id="7" name="Slide Number Placeholder 6"/>
-          <p:cNvSpPr>
-            <a:spLocks noGrp="1"/>
-          </p:cNvSpPr>
-          <p:nvPr>
-            <p:ph type="sldNum" sz="quarter" idx="5"/>
-          </p:nvPr>
-        </p:nvSpPr>
-        <p:spPr>
-          <a:xfrm>
-            <a:off x="3884613" y="8685213"/>
-            <a:ext cx="2971800" cy="458787"/>
-          </a:xfrm>
-          <a:prstGeom prst="rect">
-            <a:avLst/>
-          </a:prstGeom>
-        </p:spPr>
-        <p:txBody>
-          <a:bodyPr vert="horz" lIns="91440" tIns="45720" rIns="91440" bIns="45720" rtlCol="0" anchor="b"/>
-          <a:lstStyle>
-            <a:lvl1pPr algn="r">
-              <a:defRPr sz="1200"/>
-            </a:lvl1pPr>
-          </a:lstStyle>
-          <a:p>
-            <a:fld id="{CE5E9CC1-C706-0F49-92D6-E571CC5EEA8F}" type="slidenum">
-              <a:rPr lang="en-US"/>
-              <a:t>‹#›</a:t>
-            </a:fld>
-            <a:endParaRPr lang="en-US"/>
-          </a:p>
-        </p:txBody>
-      </p:sp>
     </p:spTree>
     <p:extLst>
       <p:ext uri="{BB962C8B-B14F-4D97-AF65-F5344CB8AC3E}">
-        <p14:creationId xmlns:p14="http://schemas.microsoft.com/office/powerpoint/2010/main" val="1024086991"/>
+        <p14:creationId xmlns:p14="http://schemas.microsoft.com/office/powerpoint/2010/main" val="1509978604"/>
       </p:ext>
     </p:extLst>
   </p:cSld>
@@ -512,10 +293,6 @@
           <a:bodyPr/>
           <a:lstStyle/>
           <a:p>
-            <a:r>
-              <a:rPr lang="en-US" dirty="0"/>
-              <a:t/>
-            </a:r>
             <a:endParaRPr lang="en-US" dirty="0"/>
           </a:p>
         </p:txBody>
@@ -600,10 +377,6 @@
           <a:bodyPr/>
           <a:lstStyle/>
           <a:p>
-            <a:r>
-              <a:rPr lang="en-US" dirty="0"/>
-              <a:t/>
-            </a:r>
             <a:endParaRPr lang="en-US" dirty="0"/>
           </a:p>
         </p:txBody>
@@ -688,10 +461,6 @@
           <a:bodyPr/>
           <a:lstStyle/>
           <a:p>
-            <a:r>
-              <a:rPr lang="en-US" dirty="0"/>
-              <a:t/>
-            </a:r>
             <a:endParaRPr lang="en-US" dirty="0"/>
           </a:p>
         </p:txBody>
@@ -776,10 +545,6 @@
           <a:bodyPr/>
           <a:lstStyle/>
           <a:p>
-            <a:r>
-              <a:rPr lang="en-US" dirty="0"/>
-              <a:t/>
-            </a:r>
             <a:endParaRPr lang="en-US" dirty="0"/>
           </a:p>
         </p:txBody>
@@ -864,10 +629,6 @@
           <a:bodyPr/>
           <a:lstStyle/>
           <a:p>
-            <a:r>
-              <a:rPr lang="en-US" dirty="0"/>
-              <a:t/>
-            </a:r>
             <a:endParaRPr lang="en-US" dirty="0"/>
           </a:p>
         </p:txBody>
@@ -952,10 +713,6 @@
           <a:bodyPr/>
           <a:lstStyle/>
           <a:p>
-            <a:r>
-              <a:rPr lang="en-US" dirty="0"/>
-              <a:t/>
-            </a:r>
             <a:endParaRPr lang="en-US" dirty="0"/>
           </a:p>
         </p:txBody>
@@ -1040,10 +797,6 @@
           <a:bodyPr/>
           <a:lstStyle/>
           <a:p>
-            <a:r>
-              <a:rPr lang="en-US" dirty="0"/>
-              <a:t/>
-            </a:r>
             <a:endParaRPr lang="en-US" dirty="0"/>
           </a:p>
         </p:txBody>
@@ -1128,10 +881,6 @@
           <a:bodyPr/>
           <a:lstStyle/>
           <a:p>
-            <a:r>
-              <a:rPr lang="en-US" dirty="0"/>
-              <a:t/>
-            </a:r>
             <a:endParaRPr lang="en-US" dirty="0"/>
           </a:p>
         </p:txBody>
@@ -1216,10 +965,6 @@
           <a:bodyPr/>
           <a:lstStyle/>
           <a:p>
-            <a:r>
-              <a:rPr lang="en-US" dirty="0"/>
-              <a:t/>
-            </a:r>
             <a:endParaRPr lang="en-US" dirty="0"/>
           </a:p>
         </p:txBody>
@@ -1304,10 +1049,6 @@
           <a:bodyPr/>
           <a:lstStyle/>
           <a:p>
-            <a:r>
-              <a:rPr lang="en-US" dirty="0"/>
-              <a:t/>
-            </a:r>
             <a:endParaRPr lang="en-US" dirty="0"/>
           </a:p>
         </p:txBody>
@@ -1392,10 +1133,6 @@
           <a:bodyPr/>
           <a:lstStyle/>
           <a:p>
-            <a:r>
-              <a:rPr lang="en-US" dirty="0"/>
-              <a:t/>
-            </a:r>
             <a:endParaRPr lang="en-US" dirty="0"/>
           </a:p>
         </p:txBody>
@@ -1480,10 +1217,6 @@
           <a:bodyPr/>
           <a:lstStyle/>
           <a:p>
-            <a:r>
-              <a:rPr lang="en-US" dirty="0"/>
-              <a:t/>
-            </a:r>
             <a:endParaRPr lang="en-US" dirty="0"/>
           </a:p>
         </p:txBody>
@@ -1568,10 +1301,6 @@
           <a:bodyPr/>
           <a:lstStyle/>
           <a:p>
-            <a:r>
-              <a:rPr lang="en-US" dirty="0"/>
-              <a:t/>
-            </a:r>
             <a:endParaRPr lang="en-US" dirty="0"/>
           </a:p>
         </p:txBody>
@@ -1645,6 +1374,11 @@
 <file path=ppt/slideMasters/slideMaster1.xml><?xml version="1.0" encoding="utf-8"?>
 <p:sldMaster xmlns:a="http://schemas.openxmlformats.org/drawingml/2006/main" xmlns:r="http://schemas.openxmlformats.org/officeDocument/2006/relationships" xmlns:p="http://schemas.openxmlformats.org/presentationml/2006/main">
   <p:cSld>
+    <p:bg>
+      <p:bgRef idx="1001">
+        <a:schemeClr val="bg1"/>
+      </p:bgRef>
+    </p:bg>
     <p:spTree>
       <p:nvGrpSpPr>
         <p:cNvPr id="1" name=""/>
@@ -1927,6 +1661,7 @@
         <a:solidFill>
           <a:srgbClr val="0B1220"/>
         </a:solidFill>
+        <a:effectLst/>
       </p:bgPr>
     </p:bg>
     <p:spTree>
@@ -1945,26 +1680,6 @@
       </p:grpSpPr>
       <p:sp>
         <p:nvSpPr>
-          <p:cNvPr id="2" name="Shape 0"/>
-          <p:cNvSpPr/>
-          <p:nvPr/>
-        </p:nvSpPr>
-        <p:spPr>
-          <a:xfrm>
-            <a:off x="0" y="6126480"/>
-            <a:ext cx="12188952" cy="731520"/>
-          </a:xfrm>
-          <a:prstGeom prst="rect">
-            <a:avLst/>
-          </a:prstGeom>
-          <a:solidFill>
-            <a:srgbClr val="111A2E"/>
-          </a:solidFill>
-          <a:ln/>
-        </p:spPr>
-      </p:sp>
-      <p:sp>
-        <p:nvSpPr>
           <p:cNvPr id="3" name="Shape 1"/>
           <p:cNvSpPr/>
           <p:nvPr/>
@@ -2004,11 +1719,11 @@
           <a:bodyPr wrap="square" rtlCol="0" anchor="ctr"/>
           <a:lstStyle/>
           <a:p>
-            <a:pPr indent="0" marL="0">
-              <a:buNone/>
-            </a:pPr>
-            <a:r>
-              <a:rPr lang="en-US" sz="5400" b="1" spc="400" kern="0" dirty="0">
+            <a:pPr marL="0" indent="0">
+              <a:buNone/>
+            </a:pPr>
+            <a:r>
+              <a:rPr lang="en-US" sz="5400" b="1" kern="0" spc="400" dirty="0">
                 <a:solidFill>
                   <a:srgbClr val="F3F4F6"/>
                 </a:solidFill>
@@ -2043,7 +1758,7 @@
           <a:bodyPr wrap="square" rtlCol="0" anchor="ctr"/>
           <a:lstStyle/>
           <a:p>
-            <a:pPr indent="0" marL="0">
+            <a:pPr marL="0" indent="0">
               <a:buNone/>
             </a:pPr>
             <a:r>
@@ -2082,7 +1797,7 @@
           <a:bodyPr wrap="square" rtlCol="0" anchor="ctr"/>
           <a:lstStyle/>
           <a:p>
-            <a:pPr indent="0" marL="0">
+            <a:pPr marL="0" indent="0">
               <a:buNone/>
             </a:pPr>
             <a:r>
@@ -2148,7 +1863,7 @@
           <a:bodyPr wrap="square" rtlCol="0" anchor="ctr"/>
           <a:lstStyle/>
           <a:p>
-            <a:pPr indent="0" marL="0">
+            <a:pPr marL="0" indent="0">
               <a:buNone/>
             </a:pPr>
             <a:r>
@@ -2187,11 +1902,11 @@
           <a:bodyPr wrap="square" rtlCol="0" anchor="ctr"/>
           <a:lstStyle/>
           <a:p>
-            <a:pPr indent="0" marL="0">
-              <a:buNone/>
-            </a:pPr>
-            <a:r>
-              <a:rPr lang="en-US" sz="1500" dirty="0">
+            <a:pPr marL="0" indent="0">
+              <a:buNone/>
+            </a:pPr>
+            <a:r>
+              <a:rPr lang="en-US" sz="1500" dirty="0" err="1" smtClean="0">
                 <a:solidFill>
                   <a:srgbClr val="F3F4F6"/>
                 </a:solidFill>
@@ -2199,77 +1914,10 @@
                 <a:ea typeface="Consolas" pitchFamily="34" charset="-122"/>
                 <a:cs typeface="Consolas" pitchFamily="34" charset="-120"/>
               </a:rPr>
-              <a:t>Ritika Bisht</a:t>
-            </a:r>
-            <a:endParaRPr lang="en-US" sz="1500" dirty="0"/>
-          </a:p>
-        </p:txBody>
-      </p:sp>
-      <p:sp>
-        <p:nvSpPr>
-          <p:cNvPr id="10" name="Text 8"/>
-          <p:cNvSpPr/>
-          <p:nvPr/>
-        </p:nvSpPr>
-        <p:spPr>
-          <a:xfrm>
-            <a:off x="914400" y="4251960"/>
-            <a:ext cx="2194560" cy="502920"/>
-          </a:xfrm>
-          <a:prstGeom prst="rect">
-            <a:avLst/>
-          </a:prstGeom>
-          <a:noFill/>
-          <a:ln/>
-        </p:spPr>
-        <p:txBody>
-          <a:bodyPr wrap="square" rtlCol="0" anchor="ctr"/>
-          <a:lstStyle/>
-          <a:p>
-            <a:pPr indent="0" marL="0">
-              <a:buNone/>
-            </a:pPr>
-            <a:r>
-              <a:rPr lang="en-US" sz="1400" b="1" dirty="0">
-                <a:solidFill>
-                  <a:srgbClr val="9CA3AF"/>
-                </a:solidFill>
-                <a:latin typeface="Segoe UI" pitchFamily="34" charset="0"/>
-                <a:ea typeface="Segoe UI" pitchFamily="34" charset="-122"/>
-                <a:cs typeface="Segoe UI" pitchFamily="34" charset="-120"/>
-              </a:rPr>
-              <a:t>Live URL</a:t>
-            </a:r>
-            <a:endParaRPr lang="en-US" sz="1400" dirty="0"/>
-          </a:p>
-        </p:txBody>
-      </p:sp>
-      <p:sp>
-        <p:nvSpPr>
-          <p:cNvPr id="11" name="Text 9"/>
-          <p:cNvSpPr/>
-          <p:nvPr/>
-        </p:nvSpPr>
-        <p:spPr>
-          <a:xfrm>
-            <a:off x="3200400" y="4251960"/>
-            <a:ext cx="8229600" cy="502920"/>
-          </a:xfrm>
-          <a:prstGeom prst="rect">
-            <a:avLst/>
-          </a:prstGeom>
-          <a:noFill/>
-          <a:ln/>
-        </p:spPr>
-        <p:txBody>
-          <a:bodyPr wrap="square" rtlCol="0" anchor="ctr"/>
-          <a:lstStyle/>
-          <a:p>
-            <a:pPr indent="0" marL="0">
-              <a:buNone/>
-            </a:pPr>
-            <a:r>
-              <a:rPr lang="en-US" sz="1500" dirty="0">
+              <a:t>Krits</a:t>
+            </a:r>
+            <a:r>
+              <a:rPr lang="en-US" sz="1500" dirty="0" smtClean="0">
                 <a:solidFill>
                   <a:srgbClr val="F3F4F6"/>
                 </a:solidFill>
@@ -2277,77 +1925,10 @@
                 <a:ea typeface="Consolas" pitchFamily="34" charset="-122"/>
                 <a:cs typeface="Consolas" pitchFamily="34" charset="-120"/>
               </a:rPr>
-              <a:t>https://demourl.com</a:t>
-            </a:r>
-            <a:endParaRPr lang="en-US" sz="1500" dirty="0"/>
-          </a:p>
-        </p:txBody>
-      </p:sp>
-      <p:sp>
-        <p:nvSpPr>
-          <p:cNvPr id="12" name="Text 10"/>
-          <p:cNvSpPr/>
-          <p:nvPr/>
-        </p:nvSpPr>
-        <p:spPr>
-          <a:xfrm>
-            <a:off x="914400" y="4754880"/>
-            <a:ext cx="2194560" cy="502920"/>
-          </a:xfrm>
-          <a:prstGeom prst="rect">
-            <a:avLst/>
-          </a:prstGeom>
-          <a:noFill/>
-          <a:ln/>
-        </p:spPr>
-        <p:txBody>
-          <a:bodyPr wrap="square" rtlCol="0" anchor="ctr"/>
-          <a:lstStyle/>
-          <a:p>
-            <a:pPr indent="0" marL="0">
-              <a:buNone/>
-            </a:pPr>
-            <a:r>
-              <a:rPr lang="en-US" sz="1400" b="1" dirty="0">
-                <a:solidFill>
-                  <a:srgbClr val="9CA3AF"/>
-                </a:solidFill>
-                <a:latin typeface="Segoe UI" pitchFamily="34" charset="0"/>
-                <a:ea typeface="Segoe UI" pitchFamily="34" charset="-122"/>
-                <a:cs typeface="Segoe UI" pitchFamily="34" charset="-120"/>
-              </a:rPr>
-              <a:t>Repo URL</a:t>
-            </a:r>
-            <a:endParaRPr lang="en-US" sz="1400" dirty="0"/>
-          </a:p>
-        </p:txBody>
-      </p:sp>
-      <p:sp>
-        <p:nvSpPr>
-          <p:cNvPr id="13" name="Text 11"/>
-          <p:cNvSpPr/>
-          <p:nvPr/>
-        </p:nvSpPr>
-        <p:spPr>
-          <a:xfrm>
-            <a:off x="3200400" y="4754880"/>
-            <a:ext cx="8229600" cy="502920"/>
-          </a:xfrm>
-          <a:prstGeom prst="rect">
-            <a:avLst/>
-          </a:prstGeom>
-          <a:noFill/>
-          <a:ln/>
-        </p:spPr>
-        <p:txBody>
-          <a:bodyPr wrap="square" rtlCol="0" anchor="ctr"/>
-          <a:lstStyle/>
-          <a:p>
-            <a:pPr indent="0" marL="0">
-              <a:buNone/>
-            </a:pPr>
-            <a:r>
-              <a:rPr lang="en-US" sz="1500" dirty="0">
+              <a:t> Code(</a:t>
+            </a:r>
+            <a:r>
+              <a:rPr lang="en-US" sz="1500" dirty="0" err="1" smtClean="0">
                 <a:solidFill>
                   <a:srgbClr val="F3F4F6"/>
                 </a:solidFill>
@@ -2355,7 +1936,190 @@
                 <a:ea typeface="Consolas" pitchFamily="34" charset="-122"/>
                 <a:cs typeface="Consolas" pitchFamily="34" charset="-120"/>
               </a:rPr>
-              <a:t>https://github/repodemo</a:t>
+              <a:t>Ritika</a:t>
+            </a:r>
+            <a:r>
+              <a:rPr lang="en-US" sz="1500" dirty="0" smtClean="0">
+                <a:solidFill>
+                  <a:srgbClr val="F3F4F6"/>
+                </a:solidFill>
+                <a:latin typeface="Consolas" pitchFamily="34" charset="0"/>
+                <a:ea typeface="Consolas" pitchFamily="34" charset="-122"/>
+                <a:cs typeface="Consolas" pitchFamily="34" charset="-120"/>
+              </a:rPr>
+              <a:t> </a:t>
+            </a:r>
+            <a:r>
+              <a:rPr lang="en-US" sz="1500" dirty="0" err="1" smtClean="0">
+                <a:solidFill>
+                  <a:srgbClr val="F3F4F6"/>
+                </a:solidFill>
+                <a:latin typeface="Consolas" pitchFamily="34" charset="0"/>
+                <a:ea typeface="Consolas" pitchFamily="34" charset="-122"/>
+                <a:cs typeface="Consolas" pitchFamily="34" charset="-120"/>
+              </a:rPr>
+              <a:t>Bisht</a:t>
+            </a:r>
+            <a:r>
+              <a:rPr lang="en-US" sz="1500" dirty="0" smtClean="0">
+                <a:solidFill>
+                  <a:srgbClr val="F3F4F6"/>
+                </a:solidFill>
+                <a:latin typeface="Consolas" pitchFamily="34" charset="0"/>
+                <a:ea typeface="Consolas" pitchFamily="34" charset="-122"/>
+                <a:cs typeface="Consolas" pitchFamily="34" charset="-120"/>
+              </a:rPr>
+              <a:t>)</a:t>
+            </a:r>
+            <a:endParaRPr lang="en-US" sz="1500" dirty="0"/>
+          </a:p>
+        </p:txBody>
+      </p:sp>
+      <p:sp>
+        <p:nvSpPr>
+          <p:cNvPr id="10" name="Text 8"/>
+          <p:cNvSpPr/>
+          <p:nvPr/>
+        </p:nvSpPr>
+        <p:spPr>
+          <a:xfrm>
+            <a:off x="914400" y="4251960"/>
+            <a:ext cx="2194560" cy="502920"/>
+          </a:xfrm>
+          <a:prstGeom prst="rect">
+            <a:avLst/>
+          </a:prstGeom>
+          <a:noFill/>
+          <a:ln/>
+        </p:spPr>
+        <p:txBody>
+          <a:bodyPr wrap="square" rtlCol="0" anchor="ctr"/>
+          <a:lstStyle/>
+          <a:p>
+            <a:pPr marL="0" indent="0">
+              <a:buNone/>
+            </a:pPr>
+            <a:r>
+              <a:rPr lang="en-US" sz="1400" b="1" dirty="0">
+                <a:solidFill>
+                  <a:srgbClr val="9CA3AF"/>
+                </a:solidFill>
+                <a:latin typeface="Segoe UI" pitchFamily="34" charset="0"/>
+                <a:ea typeface="Segoe UI" pitchFamily="34" charset="-122"/>
+                <a:cs typeface="Segoe UI" pitchFamily="34" charset="-120"/>
+              </a:rPr>
+              <a:t>Live URL</a:t>
+            </a:r>
+            <a:endParaRPr lang="en-US" sz="1400" dirty="0"/>
+          </a:p>
+        </p:txBody>
+      </p:sp>
+      <p:sp>
+        <p:nvSpPr>
+          <p:cNvPr id="11" name="Text 9"/>
+          <p:cNvSpPr/>
+          <p:nvPr/>
+        </p:nvSpPr>
+        <p:spPr>
+          <a:xfrm>
+            <a:off x="3200400" y="4251960"/>
+            <a:ext cx="8229600" cy="502920"/>
+          </a:xfrm>
+          <a:prstGeom prst="rect">
+            <a:avLst/>
+          </a:prstGeom>
+          <a:noFill/>
+          <a:ln/>
+        </p:spPr>
+        <p:txBody>
+          <a:bodyPr wrap="square" rtlCol="0" anchor="ctr"/>
+          <a:lstStyle/>
+          <a:p>
+            <a:r>
+              <a:rPr lang="en-US" sz="1500" dirty="0">
+                <a:solidFill>
+                  <a:srgbClr val="F3F4F6"/>
+                </a:solidFill>
+                <a:latin typeface="Consolas" pitchFamily="34" charset="0"/>
+                <a:ea typeface="Consolas" pitchFamily="34" charset="-122"/>
+                <a:cs typeface="Consolas" pitchFamily="34" charset="-120"/>
+              </a:rPr>
+              <a:t>https://intain-full-stack-hackathon-solutio-pi.vercel.app/login</a:t>
+            </a:r>
+            <a:endParaRPr lang="en-US" sz="1500" dirty="0"/>
+          </a:p>
+        </p:txBody>
+      </p:sp>
+      <p:sp>
+        <p:nvSpPr>
+          <p:cNvPr id="12" name="Text 10"/>
+          <p:cNvSpPr/>
+          <p:nvPr/>
+        </p:nvSpPr>
+        <p:spPr>
+          <a:xfrm>
+            <a:off x="914400" y="4754880"/>
+            <a:ext cx="2194560" cy="502920"/>
+          </a:xfrm>
+          <a:prstGeom prst="rect">
+            <a:avLst/>
+          </a:prstGeom>
+          <a:noFill/>
+          <a:ln/>
+        </p:spPr>
+        <p:txBody>
+          <a:bodyPr wrap="square" rtlCol="0" anchor="ctr"/>
+          <a:lstStyle/>
+          <a:p>
+            <a:pPr marL="0" indent="0">
+              <a:buNone/>
+            </a:pPr>
+            <a:r>
+              <a:rPr lang="en-US" sz="1400" b="1" dirty="0">
+                <a:solidFill>
+                  <a:srgbClr val="9CA3AF"/>
+                </a:solidFill>
+                <a:latin typeface="Segoe UI" pitchFamily="34" charset="0"/>
+                <a:ea typeface="Segoe UI" pitchFamily="34" charset="-122"/>
+                <a:cs typeface="Segoe UI" pitchFamily="34" charset="-120"/>
+              </a:rPr>
+              <a:t>Repo URL</a:t>
+            </a:r>
+            <a:endParaRPr lang="en-US" sz="1400" dirty="0"/>
+          </a:p>
+        </p:txBody>
+      </p:sp>
+      <p:sp>
+        <p:nvSpPr>
+          <p:cNvPr id="13" name="Text 11"/>
+          <p:cNvSpPr/>
+          <p:nvPr/>
+        </p:nvSpPr>
+        <p:spPr>
+          <a:xfrm>
+            <a:off x="3200400" y="4754880"/>
+            <a:ext cx="8229600" cy="502920"/>
+          </a:xfrm>
+          <a:prstGeom prst="rect">
+            <a:avLst/>
+          </a:prstGeom>
+          <a:noFill/>
+          <a:ln/>
+        </p:spPr>
+        <p:txBody>
+          <a:bodyPr wrap="square" rtlCol="0" anchor="ctr"/>
+          <a:lstStyle/>
+          <a:p>
+            <a:r>
+              <a:rPr lang="en-US" sz="1500" dirty="0">
+                <a:solidFill>
+                  <a:srgbClr val="F3F4F6"/>
+                </a:solidFill>
+                <a:latin typeface="Consolas" pitchFamily="34" charset="0"/>
+                <a:ea typeface="Consolas" pitchFamily="34" charset="-122"/>
+                <a:cs typeface="Consolas" pitchFamily="34" charset="-120"/>
+              </a:rPr>
+              <a:t>https://github.com/HeyRitika1/Intain-FullStack-Hackathon-Solution</a:t>
             </a:r>
             <a:endParaRPr lang="en-US" sz="1500" dirty="0"/>
           </a:p>
@@ -2382,20 +2146,9 @@
           <a:bodyPr wrap="square" rtlCol="0" anchor="ctr"/>
           <a:lstStyle/>
           <a:p>
-            <a:pPr algn="l" indent="0" marL="0">
-              <a:buNone/>
-            </a:pPr>
-            <a:r>
-              <a:rPr lang="en-US" sz="1200" i="1" dirty="0">
-                <a:solidFill>
-                  <a:srgbClr val="9CA3AF"/>
-                </a:solidFill>
-                <a:latin typeface="Segoe UI" pitchFamily="34" charset="0"/>
-                <a:ea typeface="Segoe UI" pitchFamily="34" charset="-122"/>
-                <a:cs typeface="Segoe UI" pitchFamily="34" charset="-120"/>
-              </a:rPr>
-              <a:t>Product pitch deck  ·  every artefact, every guarantee, one place</a:t>
-            </a:r>
+            <a:pPr marL="0" indent="0" algn="l">
+              <a:buNone/>
+            </a:pPr>
             <a:endParaRPr lang="en-US" sz="1200" dirty="0"/>
           </a:p>
         </p:txBody>
@@ -2416,6 +2169,7 @@
         <a:solidFill>
           <a:srgbClr val="0B1220"/>
         </a:solidFill>
+        <a:effectLst/>
       </p:bgPr>
     </p:bg>
     <p:spTree>
@@ -2473,7 +2227,7 @@
           <a:bodyPr wrap="square" rtlCol="0" anchor="ctr"/>
           <a:lstStyle/>
           <a:p>
-            <a:pPr indent="0" marL="0">
+            <a:pPr marL="0" indent="0">
               <a:buNone/>
             </a:pPr>
             <a:r>
@@ -2512,7 +2266,7 @@
           <a:bodyPr wrap="square" rtlCol="0" anchor="ctr"/>
           <a:lstStyle/>
           <a:p>
-            <a:pPr algn="r" indent="0" marL="0">
+            <a:pPr marL="0" indent="0" algn="r">
               <a:buNone/>
             </a:pPr>
             <a:r>
@@ -2551,7 +2305,7 @@
           <a:bodyPr wrap="square" rtlCol="0" anchor="ctr"/>
           <a:lstStyle/>
           <a:p>
-            <a:pPr indent="0" marL="0">
+            <a:pPr marL="0" indent="0">
               <a:buNone/>
             </a:pPr>
             <a:r>
@@ -2610,7 +2364,7 @@
           <a:bodyPr wrap="square" rtlCol="0" anchor="ctr"/>
           <a:lstStyle/>
           <a:p>
-            <a:pPr indent="0" marL="0">
+            <a:pPr marL="0" indent="0">
               <a:buNone/>
             </a:pPr>
             <a:r>
@@ -2676,7 +2430,7 @@
           <a:bodyPr wrap="square" rtlCol="0" anchor="ctr"/>
           <a:lstStyle/>
           <a:p>
-            <a:pPr indent="0" marL="0">
+            <a:pPr marL="0" indent="0">
               <a:buNone/>
             </a:pPr>
             <a:r>
@@ -2974,7 +2728,7 @@
           <a:bodyPr wrap="square" rtlCol="0" anchor="ctr"/>
           <a:lstStyle/>
           <a:p>
-            <a:pPr indent="0" marL="0">
+            <a:pPr marL="0" indent="0">
               <a:buNone/>
             </a:pPr>
             <a:r>
@@ -3104,7 +2858,7 @@
           <a:bodyPr wrap="square" rtlCol="0" anchor="ctr"/>
           <a:lstStyle/>
           <a:p>
-            <a:pPr indent="0" marL="0">
+            <a:pPr marL="0" indent="0">
               <a:buNone/>
             </a:pPr>
             <a:r>
@@ -3223,6 +2977,7 @@
         <a:solidFill>
           <a:srgbClr val="0B1220"/>
         </a:solidFill>
+        <a:effectLst/>
       </p:bgPr>
     </p:bg>
     <p:spTree>
@@ -3280,7 +3035,7 @@
           <a:bodyPr wrap="square" rtlCol="0" anchor="ctr"/>
           <a:lstStyle/>
           <a:p>
-            <a:pPr indent="0" marL="0">
+            <a:pPr marL="0" indent="0">
               <a:buNone/>
             </a:pPr>
             <a:r>
@@ -3319,7 +3074,7 @@
           <a:bodyPr wrap="square" rtlCol="0" anchor="ctr"/>
           <a:lstStyle/>
           <a:p>
-            <a:pPr indent="0" marL="0">
+            <a:pPr marL="0" indent="0">
               <a:buNone/>
             </a:pPr>
             <a:r>
@@ -3378,7 +3133,7 @@
           <a:bodyPr wrap="square" rtlCol="0" anchor="ctr"/>
           <a:lstStyle/>
           <a:p>
-            <a:pPr indent="0" marL="0">
+            <a:pPr marL="0" indent="0">
               <a:buNone/>
             </a:pPr>
             <a:r>
@@ -3464,7 +3219,7 @@
           <a:bodyPr wrap="square" rtlCol="0" anchor="ctr"/>
           <a:lstStyle/>
           <a:p>
-            <a:pPr indent="0" marL="0">
+            <a:pPr marL="0" indent="0">
               <a:buNone/>
             </a:pPr>
             <a:r>
@@ -3503,7 +3258,7 @@
           <a:bodyPr wrap="square" rtlCol="0" anchor="ctr"/>
           <a:lstStyle/>
           <a:p>
-            <a:pPr indent="0" marL="0">
+            <a:pPr marL="0" indent="0">
               <a:buNone/>
             </a:pPr>
             <a:r>
@@ -3542,7 +3297,7 @@
           <a:bodyPr wrap="square" rtlCol="0" anchor="ctr"/>
           <a:lstStyle/>
           <a:p>
-            <a:pPr indent="0" marL="0">
+            <a:pPr marL="0" indent="0">
               <a:buNone/>
             </a:pPr>
             <a:r>
@@ -3628,7 +3383,7 @@
           <a:bodyPr wrap="square" rtlCol="0" anchor="ctr"/>
           <a:lstStyle/>
           <a:p>
-            <a:pPr indent="0" marL="0">
+            <a:pPr marL="0" indent="0">
               <a:buNone/>
             </a:pPr>
             <a:r>
@@ -3667,7 +3422,7 @@
           <a:bodyPr wrap="square" rtlCol="0" anchor="ctr"/>
           <a:lstStyle/>
           <a:p>
-            <a:pPr indent="0" marL="0">
+            <a:pPr marL="0" indent="0">
               <a:buNone/>
             </a:pPr>
             <a:r>
@@ -3706,7 +3461,7 @@
           <a:bodyPr wrap="square" rtlCol="0" anchor="ctr"/>
           <a:lstStyle/>
           <a:p>
-            <a:pPr indent="0" marL="0">
+            <a:pPr marL="0" indent="0">
               <a:buNone/>
             </a:pPr>
             <a:r>
@@ -3792,7 +3547,7 @@
           <a:bodyPr wrap="square" rtlCol="0" anchor="ctr"/>
           <a:lstStyle/>
           <a:p>
-            <a:pPr indent="0" marL="0">
+            <a:pPr marL="0" indent="0">
               <a:buNone/>
             </a:pPr>
             <a:r>
@@ -3831,7 +3586,7 @@
           <a:bodyPr wrap="square" rtlCol="0" anchor="ctr"/>
           <a:lstStyle/>
           <a:p>
-            <a:pPr indent="0" marL="0">
+            <a:pPr marL="0" indent="0">
               <a:buNone/>
             </a:pPr>
             <a:r>
@@ -3870,7 +3625,7 @@
           <a:bodyPr wrap="square" rtlCol="0" anchor="ctr"/>
           <a:lstStyle/>
           <a:p>
-            <a:pPr indent="0" marL="0">
+            <a:pPr marL="0" indent="0">
               <a:buNone/>
             </a:pPr>
             <a:r>
@@ -3956,7 +3711,7 @@
           <a:bodyPr wrap="square" rtlCol="0" anchor="ctr"/>
           <a:lstStyle/>
           <a:p>
-            <a:pPr indent="0" marL="0">
+            <a:pPr marL="0" indent="0">
               <a:buNone/>
             </a:pPr>
             <a:r>
@@ -3995,7 +3750,7 @@
           <a:bodyPr wrap="square" rtlCol="0" anchor="ctr"/>
           <a:lstStyle/>
           <a:p>
-            <a:pPr indent="0" marL="0">
+            <a:pPr marL="0" indent="0">
               <a:buNone/>
             </a:pPr>
             <a:r>
@@ -4034,7 +3789,7 @@
           <a:bodyPr wrap="square" rtlCol="0" anchor="ctr"/>
           <a:lstStyle/>
           <a:p>
-            <a:pPr indent="0" marL="0">
+            <a:pPr marL="0" indent="0">
               <a:buNone/>
             </a:pPr>
             <a:r>
@@ -4120,7 +3875,7 @@
           <a:bodyPr wrap="square" rtlCol="0" anchor="ctr"/>
           <a:lstStyle/>
           <a:p>
-            <a:pPr indent="0" marL="0">
+            <a:pPr marL="0" indent="0">
               <a:buNone/>
             </a:pPr>
             <a:r>
@@ -4159,7 +3914,7 @@
           <a:bodyPr wrap="square" rtlCol="0" anchor="ctr"/>
           <a:lstStyle/>
           <a:p>
-            <a:pPr indent="0" marL="0">
+            <a:pPr marL="0" indent="0">
               <a:buNone/>
             </a:pPr>
             <a:r>
@@ -4198,7 +3953,7 @@
           <a:bodyPr wrap="square" rtlCol="0" anchor="ctr"/>
           <a:lstStyle/>
           <a:p>
-            <a:pPr indent="0" marL="0">
+            <a:pPr marL="0" indent="0">
               <a:buNone/>
             </a:pPr>
             <a:r>
@@ -4284,7 +4039,7 @@
           <a:bodyPr wrap="square" rtlCol="0" anchor="ctr"/>
           <a:lstStyle/>
           <a:p>
-            <a:pPr indent="0" marL="0">
+            <a:pPr marL="0" indent="0">
               <a:buNone/>
             </a:pPr>
             <a:r>
@@ -4323,7 +4078,7 @@
           <a:bodyPr wrap="square" rtlCol="0" anchor="ctr"/>
           <a:lstStyle/>
           <a:p>
-            <a:pPr indent="0" marL="0">
+            <a:pPr marL="0" indent="0">
               <a:buNone/>
             </a:pPr>
             <a:r>
@@ -4362,7 +4117,7 @@
           <a:bodyPr wrap="square" rtlCol="0" anchor="ctr"/>
           <a:lstStyle/>
           <a:p>
-            <a:pPr indent="0" marL="0">
+            <a:pPr marL="0" indent="0">
               <a:buNone/>
             </a:pPr>
             <a:r>
@@ -4448,7 +4203,7 @@
           <a:bodyPr wrap="square" rtlCol="0" anchor="ctr"/>
           <a:lstStyle/>
           <a:p>
-            <a:pPr indent="0" marL="0">
+            <a:pPr marL="0" indent="0">
               <a:buNone/>
             </a:pPr>
             <a:r>
@@ -4487,7 +4242,7 @@
           <a:bodyPr wrap="square" rtlCol="0" anchor="ctr"/>
           <a:lstStyle/>
           <a:p>
-            <a:pPr indent="0" marL="0">
+            <a:pPr marL="0" indent="0">
               <a:buNone/>
             </a:pPr>
             <a:r>
@@ -4526,7 +4281,7 @@
           <a:bodyPr wrap="square" rtlCol="0" anchor="ctr"/>
           <a:lstStyle/>
           <a:p>
-            <a:pPr indent="0" marL="0">
+            <a:pPr marL="0" indent="0">
               <a:buNone/>
             </a:pPr>
             <a:r>
@@ -4612,7 +4367,7 @@
           <a:bodyPr wrap="square" rtlCol="0" anchor="ctr"/>
           <a:lstStyle/>
           <a:p>
-            <a:pPr indent="0" marL="0">
+            <a:pPr marL="0" indent="0">
               <a:buNone/>
             </a:pPr>
             <a:r>
@@ -4651,7 +4406,7 @@
           <a:bodyPr wrap="square" rtlCol="0" anchor="ctr"/>
           <a:lstStyle/>
           <a:p>
-            <a:pPr indent="0" marL="0">
+            <a:pPr marL="0" indent="0">
               <a:buNone/>
             </a:pPr>
             <a:r>
@@ -4690,7 +4445,7 @@
           <a:bodyPr wrap="square" rtlCol="0" anchor="ctr"/>
           <a:lstStyle/>
           <a:p>
-            <a:pPr indent="0" marL="0">
+            <a:pPr marL="0" indent="0">
               <a:buNone/>
             </a:pPr>
             <a:r>
@@ -4724,6 +4479,7 @@
         <a:solidFill>
           <a:srgbClr val="0B1220"/>
         </a:solidFill>
+        <a:effectLst/>
       </p:bgPr>
     </p:bg>
     <p:spTree>
@@ -4781,7 +4537,7 @@
           <a:bodyPr wrap="square" rtlCol="0" anchor="ctr"/>
           <a:lstStyle/>
           <a:p>
-            <a:pPr indent="0" marL="0">
+            <a:pPr marL="0" indent="0">
               <a:buNone/>
             </a:pPr>
             <a:r>
@@ -4820,7 +4576,7 @@
           <a:bodyPr wrap="square" rtlCol="0" anchor="ctr"/>
           <a:lstStyle/>
           <a:p>
-            <a:pPr indent="0" marL="0">
+            <a:pPr marL="0" indent="0">
               <a:buNone/>
             </a:pPr>
             <a:r>
@@ -4879,7 +4635,7 @@
           <a:bodyPr wrap="square" rtlCol="0" anchor="ctr"/>
           <a:lstStyle/>
           <a:p>
-            <a:pPr indent="0" marL="0">
+            <a:pPr marL="0" indent="0">
               <a:buNone/>
             </a:pPr>
             <a:r>
@@ -4945,7 +4701,7 @@
           <a:bodyPr wrap="square" rtlCol="0" anchor="ctr"/>
           <a:lstStyle/>
           <a:p>
-            <a:pPr indent="0" marL="0">
+            <a:pPr marL="0" indent="0">
               <a:buNone/>
             </a:pPr>
             <a:r>
@@ -4984,7 +4740,7 @@
           <a:bodyPr wrap="square" rtlCol="0" anchor="ctr"/>
           <a:lstStyle/>
           <a:p>
-            <a:pPr indent="0" marL="0">
+            <a:pPr marL="0" indent="0">
               <a:buNone/>
             </a:pPr>
             <a:r>
@@ -4998,9 +4754,6 @@
               </a:rPr>
               <a:t>recordHash = sha256(</a:t>
             </a:r>
-            <a:pPr indent="0" marL="0">
-              <a:buNone/>
-            </a:pPr>
             <a:r>
               <a:rPr lang="en-US" sz="1300" dirty="0">
                 <a:solidFill>
@@ -5012,9 +4765,6 @@
               </a:rPr>
               <a:t>canonicalStringify(payload)</a:t>
             </a:r>
-            <a:pPr indent="0" marL="0">
-              <a:buNone/>
-            </a:pPr>
             <a:r>
               <a:rPr lang="en-US" sz="1300" dirty="0">
                 <a:solidFill>
@@ -5226,7 +4976,7 @@
           <a:bodyPr wrap="square" rtlCol="0" anchor="ctr"/>
           <a:lstStyle/>
           <a:p>
-            <a:pPr indent="0" marL="0">
+            <a:pPr marL="0" indent="0">
               <a:buNone/>
             </a:pPr>
             <a:r>
@@ -5440,7 +5190,7 @@
           <a:bodyPr wrap="square" rtlCol="0" anchor="ctr"/>
           <a:lstStyle/>
           <a:p>
-            <a:pPr indent="0" marL="0">
+            <a:pPr marL="0" indent="0">
               <a:buNone/>
             </a:pPr>
             <a:r>
@@ -5479,7 +5229,7 @@
           <a:bodyPr wrap="square" rtlCol="0" anchor="ctr"/>
           <a:lstStyle/>
           <a:p>
-            <a:pPr indent="0" marL="0">
+            <a:pPr marL="0" indent="0">
               <a:buNone/>
             </a:pPr>
             <a:r>
@@ -5513,6 +5263,7 @@
         <a:solidFill>
           <a:srgbClr val="0B1220"/>
         </a:solidFill>
+        <a:effectLst/>
       </p:bgPr>
     </p:bg>
     <p:spTree>
@@ -5570,7 +5321,7 @@
           <a:bodyPr wrap="square" rtlCol="0" anchor="ctr"/>
           <a:lstStyle/>
           <a:p>
-            <a:pPr indent="0" marL="0">
+            <a:pPr marL="0" indent="0">
               <a:buNone/>
             </a:pPr>
             <a:r>
@@ -5609,7 +5360,7 @@
           <a:bodyPr wrap="square" rtlCol="0" anchor="ctr"/>
           <a:lstStyle/>
           <a:p>
-            <a:pPr indent="0" marL="0">
+            <a:pPr marL="0" indent="0">
               <a:buNone/>
             </a:pPr>
             <a:r>
@@ -5668,7 +5419,7 @@
           <a:bodyPr wrap="square" rtlCol="0" anchor="ctr"/>
           <a:lstStyle/>
           <a:p>
-            <a:pPr indent="0" marL="0">
+            <a:pPr marL="0" indent="0">
               <a:buNone/>
             </a:pPr>
             <a:r>
@@ -5734,7 +5485,7 @@
           <a:bodyPr wrap="square" rtlCol="0" anchor="ctr"/>
           <a:lstStyle/>
           <a:p>
-            <a:pPr indent="0" marL="0">
+            <a:pPr marL="0" indent="0">
               <a:buNone/>
             </a:pPr>
             <a:r>
@@ -5773,7 +5524,7 @@
           <a:bodyPr wrap="square" rtlCol="0" anchor="ctr"/>
           <a:lstStyle/>
           <a:p>
-            <a:pPr indent="0" marL="0">
+            <a:pPr marL="0" indent="0">
               <a:buNone/>
             </a:pPr>
             <a:r>
@@ -5812,7 +5563,7 @@
           <a:bodyPr wrap="square" rtlCol="0" anchor="ctr"/>
           <a:lstStyle/>
           <a:p>
-            <a:pPr indent="0" marL="0">
+            <a:pPr marL="0" indent="0">
               <a:buNone/>
             </a:pPr>
             <a:r>
@@ -5851,7 +5602,7 @@
           <a:bodyPr wrap="square" rtlCol="0" anchor="ctr"/>
           <a:lstStyle/>
           <a:p>
-            <a:pPr indent="0" marL="0">
+            <a:pPr marL="0" indent="0">
               <a:buNone/>
             </a:pPr>
             <a:r>
@@ -5890,7 +5641,7 @@
           <a:bodyPr wrap="square" rtlCol="0" anchor="ctr"/>
           <a:lstStyle/>
           <a:p>
-            <a:pPr indent="0" marL="0">
+            <a:pPr marL="0" indent="0">
               <a:buNone/>
             </a:pPr>
             <a:r>
@@ -5929,7 +5680,7 @@
           <a:bodyPr wrap="square" rtlCol="0" anchor="ctr"/>
           <a:lstStyle/>
           <a:p>
-            <a:pPr indent="0" marL="0">
+            <a:pPr marL="0" indent="0">
               <a:buNone/>
             </a:pPr>
             <a:r>
@@ -5968,7 +5719,7 @@
           <a:bodyPr wrap="square" rtlCol="0" anchor="ctr"/>
           <a:lstStyle/>
           <a:p>
-            <a:pPr indent="0" marL="0">
+            <a:pPr marL="0" indent="0">
               <a:buNone/>
             </a:pPr>
             <a:r>
@@ -6007,7 +5758,7 @@
           <a:bodyPr wrap="square" rtlCol="0" anchor="ctr"/>
           <a:lstStyle/>
           <a:p>
-            <a:pPr indent="0" marL="0">
+            <a:pPr marL="0" indent="0">
               <a:buNone/>
             </a:pPr>
             <a:r>
@@ -6046,7 +5797,7 @@
           <a:bodyPr wrap="square" rtlCol="0" anchor="ctr"/>
           <a:lstStyle/>
           <a:p>
-            <a:pPr indent="0" marL="0">
+            <a:pPr marL="0" indent="0">
               <a:buNone/>
             </a:pPr>
             <a:r>
@@ -6085,7 +5836,7 @@
           <a:bodyPr wrap="square" rtlCol="0" anchor="ctr"/>
           <a:lstStyle/>
           <a:p>
-            <a:pPr indent="0" marL="0">
+            <a:pPr marL="0" indent="0">
               <a:buNone/>
             </a:pPr>
             <a:r>
@@ -6124,7 +5875,7 @@
           <a:bodyPr wrap="square" rtlCol="0" anchor="ctr"/>
           <a:lstStyle/>
           <a:p>
-            <a:pPr indent="0" marL="0">
+            <a:pPr marL="0" indent="0">
               <a:buNone/>
             </a:pPr>
             <a:r>
@@ -6163,7 +5914,7 @@
           <a:bodyPr wrap="square" rtlCol="0" anchor="ctr"/>
           <a:lstStyle/>
           <a:p>
-            <a:pPr indent="0" marL="0">
+            <a:pPr marL="0" indent="0">
               <a:buNone/>
             </a:pPr>
             <a:r>
@@ -6202,7 +5953,7 @@
           <a:bodyPr wrap="square" rtlCol="0" anchor="ctr"/>
           <a:lstStyle/>
           <a:p>
-            <a:pPr indent="0" marL="0">
+            <a:pPr marL="0" indent="0">
               <a:buNone/>
             </a:pPr>
             <a:r>
@@ -6241,7 +5992,7 @@
           <a:bodyPr wrap="square" rtlCol="0" anchor="ctr"/>
           <a:lstStyle/>
           <a:p>
-            <a:pPr indent="0" marL="0">
+            <a:pPr marL="0" indent="0">
               <a:buNone/>
             </a:pPr>
             <a:r>
@@ -6302,7 +6053,7 @@
           <a:bodyPr wrap="square" rtlCol="0" anchor="ctr"/>
           <a:lstStyle/>
           <a:p>
-            <a:pPr algn="ctr" indent="0" marL="0">
+            <a:pPr marL="0" indent="0" algn="ctr">
               <a:buNone/>
             </a:pPr>
             <a:r>
@@ -6336,6 +6087,7 @@
         <a:solidFill>
           <a:srgbClr val="0B1220"/>
         </a:solidFill>
+        <a:effectLst/>
       </p:bgPr>
     </p:bg>
     <p:spTree>
@@ -6393,7 +6145,7 @@
           <a:bodyPr wrap="square" rtlCol="0" anchor="ctr"/>
           <a:lstStyle/>
           <a:p>
-            <a:pPr indent="0" marL="0">
+            <a:pPr marL="0" indent="0">
               <a:buNone/>
             </a:pPr>
             <a:r>
@@ -6432,7 +6184,7 @@
           <a:bodyPr wrap="square" rtlCol="0" anchor="ctr"/>
           <a:lstStyle/>
           <a:p>
-            <a:pPr indent="0" marL="0">
+            <a:pPr marL="0" indent="0">
               <a:buNone/>
             </a:pPr>
             <a:r>
@@ -6491,7 +6243,7 @@
           <a:bodyPr wrap="square" rtlCol="0" anchor="ctr"/>
           <a:lstStyle/>
           <a:p>
-            <a:pPr indent="0" marL="0">
+            <a:pPr marL="0" indent="0">
               <a:buNone/>
             </a:pPr>
             <a:r>
@@ -6530,7 +6282,7 @@
           <a:bodyPr wrap="square" rtlCol="0" anchor="ctr"/>
           <a:lstStyle/>
           <a:p>
-            <a:pPr indent="0" marL="0">
+            <a:pPr marL="0" indent="0">
               <a:buNone/>
             </a:pPr>
             <a:r>
@@ -6569,7 +6321,7 @@
           <a:bodyPr wrap="square" rtlCol="0" anchor="ctr"/>
           <a:lstStyle/>
           <a:p>
-            <a:pPr indent="0" marL="0">
+            <a:pPr marL="0" indent="0">
               <a:buNone/>
             </a:pPr>
             <a:r>
@@ -6608,7 +6360,7 @@
           <a:bodyPr wrap="square" rtlCol="0" anchor="ctr"/>
           <a:lstStyle/>
           <a:p>
-            <a:pPr indent="0" marL="0">
+            <a:pPr marL="0" indent="0">
               <a:buNone/>
             </a:pPr>
             <a:r>
@@ -6647,7 +6399,7 @@
           <a:bodyPr wrap="square" rtlCol="0" anchor="ctr"/>
           <a:lstStyle/>
           <a:p>
-            <a:pPr indent="0" marL="0">
+            <a:pPr marL="0" indent="0">
               <a:buNone/>
             </a:pPr>
             <a:r>
@@ -6686,7 +6438,7 @@
           <a:bodyPr wrap="square" rtlCol="0" anchor="ctr"/>
           <a:lstStyle/>
           <a:p>
-            <a:pPr indent="0" marL="0">
+            <a:pPr marL="0" indent="0">
               <a:buNone/>
             </a:pPr>
             <a:r>
@@ -6725,7 +6477,7 @@
           <a:bodyPr wrap="square" rtlCol="0" anchor="ctr"/>
           <a:lstStyle/>
           <a:p>
-            <a:pPr indent="0" marL="0">
+            <a:pPr marL="0" indent="0">
               <a:buNone/>
             </a:pPr>
             <a:r>
@@ -6764,7 +6516,7 @@
           <a:bodyPr wrap="square" rtlCol="0" anchor="ctr"/>
           <a:lstStyle/>
           <a:p>
-            <a:pPr indent="0" marL="0">
+            <a:pPr marL="0" indent="0">
               <a:buNone/>
             </a:pPr>
             <a:r>
@@ -6803,7 +6555,7 @@
           <a:bodyPr wrap="square" rtlCol="0" anchor="ctr"/>
           <a:lstStyle/>
           <a:p>
-            <a:pPr indent="0" marL="0">
+            <a:pPr marL="0" indent="0">
               <a:buNone/>
             </a:pPr>
             <a:r>
@@ -6842,7 +6594,7 @@
           <a:bodyPr wrap="square" rtlCol="0" anchor="ctr"/>
           <a:lstStyle/>
           <a:p>
-            <a:pPr indent="0" marL="0">
+            <a:pPr marL="0" indent="0">
               <a:buNone/>
             </a:pPr>
             <a:r>
@@ -6881,7 +6633,7 @@
           <a:bodyPr wrap="square" rtlCol="0" anchor="ctr"/>
           <a:lstStyle/>
           <a:p>
-            <a:pPr indent="0" marL="0">
+            <a:pPr marL="0" indent="0">
               <a:buNone/>
             </a:pPr>
             <a:r>
@@ -6920,7 +6672,7 @@
           <a:bodyPr wrap="square" rtlCol="0" anchor="ctr"/>
           <a:lstStyle/>
           <a:p>
-            <a:pPr indent="0" marL="0">
+            <a:pPr marL="0" indent="0">
               <a:buNone/>
             </a:pPr>
             <a:r>
@@ -6959,7 +6711,7 @@
           <a:bodyPr wrap="square" rtlCol="0" anchor="ctr"/>
           <a:lstStyle/>
           <a:p>
-            <a:pPr indent="0" marL="0">
+            <a:pPr marL="0" indent="0">
               <a:buNone/>
             </a:pPr>
             <a:r>
@@ -6998,7 +6750,7 @@
           <a:bodyPr wrap="square" rtlCol="0" anchor="ctr"/>
           <a:lstStyle/>
           <a:p>
-            <a:pPr indent="0" marL="0">
+            <a:pPr marL="0" indent="0">
               <a:buNone/>
             </a:pPr>
             <a:r>
@@ -7037,7 +6789,7 @@
           <a:bodyPr wrap="square" rtlCol="0" anchor="ctr"/>
           <a:lstStyle/>
           <a:p>
-            <a:pPr indent="0" marL="0">
+            <a:pPr marL="0" indent="0">
               <a:buNone/>
             </a:pPr>
             <a:r>
@@ -7076,7 +6828,7 @@
           <a:bodyPr wrap="square" rtlCol="0" anchor="ctr"/>
           <a:lstStyle/>
           <a:p>
-            <a:pPr indent="0" marL="0">
+            <a:pPr marL="0" indent="0">
               <a:buNone/>
             </a:pPr>
             <a:r>
@@ -7115,7 +6867,7 @@
           <a:bodyPr wrap="square" rtlCol="0" anchor="ctr"/>
           <a:lstStyle/>
           <a:p>
-            <a:pPr indent="0" marL="0">
+            <a:pPr marL="0" indent="0">
               <a:buNone/>
             </a:pPr>
             <a:r>
@@ -7154,7 +6906,7 @@
           <a:bodyPr wrap="square" rtlCol="0" anchor="ctr"/>
           <a:lstStyle/>
           <a:p>
-            <a:pPr indent="0" marL="0">
+            <a:pPr marL="0" indent="0">
               <a:buNone/>
             </a:pPr>
             <a:r>
@@ -7193,7 +6945,7 @@
           <a:bodyPr wrap="square" rtlCol="0" anchor="ctr"/>
           <a:lstStyle/>
           <a:p>
-            <a:pPr indent="0" marL="0">
+            <a:pPr marL="0" indent="0">
               <a:buNone/>
             </a:pPr>
             <a:r>
@@ -7232,7 +6984,7 @@
           <a:bodyPr wrap="square" rtlCol="0" anchor="ctr"/>
           <a:lstStyle/>
           <a:p>
-            <a:pPr indent="0" marL="0">
+            <a:pPr marL="0" indent="0">
               <a:buNone/>
             </a:pPr>
             <a:r>
@@ -7271,7 +7023,7 @@
           <a:bodyPr wrap="square" rtlCol="0" anchor="ctr"/>
           <a:lstStyle/>
           <a:p>
-            <a:pPr indent="0" marL="0">
+            <a:pPr marL="0" indent="0">
               <a:buNone/>
             </a:pPr>
             <a:r>
@@ -7310,7 +7062,7 @@
           <a:bodyPr wrap="square" rtlCol="0" anchor="ctr"/>
           <a:lstStyle/>
           <a:p>
-            <a:pPr indent="0" marL="0">
+            <a:pPr marL="0" indent="0">
               <a:buNone/>
             </a:pPr>
             <a:r>
@@ -7349,7 +7101,7 @@
           <a:bodyPr wrap="square" rtlCol="0" anchor="ctr"/>
           <a:lstStyle/>
           <a:p>
-            <a:pPr indent="0" marL="0">
+            <a:pPr marL="0" indent="0">
               <a:buNone/>
             </a:pPr>
             <a:r>
@@ -7388,7 +7140,7 @@
           <a:bodyPr wrap="square" rtlCol="0" anchor="ctr"/>
           <a:lstStyle/>
           <a:p>
-            <a:pPr indent="0" marL="0">
+            <a:pPr marL="0" indent="0">
               <a:buNone/>
             </a:pPr>
             <a:r>
@@ -7427,7 +7179,7 @@
           <a:bodyPr wrap="square" rtlCol="0" anchor="ctr"/>
           <a:lstStyle/>
           <a:p>
-            <a:pPr indent="0" marL="0">
+            <a:pPr marL="0" indent="0">
               <a:buNone/>
             </a:pPr>
             <a:r>
@@ -7466,7 +7218,7 @@
           <a:bodyPr wrap="square" rtlCol="0" anchor="ctr"/>
           <a:lstStyle/>
           <a:p>
-            <a:pPr indent="0" marL="0">
+            <a:pPr marL="0" indent="0">
               <a:buNone/>
             </a:pPr>
             <a:r>
@@ -7505,7 +7257,7 @@
           <a:bodyPr wrap="square" rtlCol="0" anchor="ctr"/>
           <a:lstStyle/>
           <a:p>
-            <a:pPr indent="0" marL="0">
+            <a:pPr marL="0" indent="0">
               <a:buNone/>
             </a:pPr>
             <a:r>
@@ -7544,7 +7296,7 @@
           <a:bodyPr wrap="square" rtlCol="0" anchor="ctr"/>
           <a:lstStyle/>
           <a:p>
-            <a:pPr indent="0" marL="0">
+            <a:pPr marL="0" indent="0">
               <a:buNone/>
             </a:pPr>
             <a:r>
@@ -7583,7 +7335,7 @@
           <a:bodyPr wrap="square" rtlCol="0" anchor="ctr"/>
           <a:lstStyle/>
           <a:p>
-            <a:pPr indent="0" marL="0">
+            <a:pPr marL="0" indent="0">
               <a:buNone/>
             </a:pPr>
             <a:r>
@@ -7622,7 +7374,7 @@
           <a:bodyPr wrap="square" rtlCol="0" anchor="ctr"/>
           <a:lstStyle/>
           <a:p>
-            <a:pPr indent="0" marL="0">
+            <a:pPr marL="0" indent="0">
               <a:buNone/>
             </a:pPr>
             <a:r>
@@ -7661,7 +7413,7 @@
           <a:bodyPr wrap="square" rtlCol="0" anchor="ctr"/>
           <a:lstStyle/>
           <a:p>
-            <a:pPr indent="0" marL="0">
+            <a:pPr marL="0" indent="0">
               <a:buNone/>
             </a:pPr>
             <a:r>
@@ -7700,7 +7452,7 @@
           <a:bodyPr wrap="square" rtlCol="0" anchor="ctr"/>
           <a:lstStyle/>
           <a:p>
-            <a:pPr indent="0" marL="0">
+            <a:pPr marL="0" indent="0">
               <a:buNone/>
             </a:pPr>
             <a:r>
@@ -7739,7 +7491,7 @@
           <a:bodyPr wrap="square" rtlCol="0" anchor="ctr"/>
           <a:lstStyle/>
           <a:p>
-            <a:pPr indent="0" marL="0">
+            <a:pPr marL="0" indent="0">
               <a:buNone/>
             </a:pPr>
             <a:r>
@@ -7778,7 +7530,7 @@
           <a:bodyPr wrap="square" rtlCol="0" anchor="ctr"/>
           <a:lstStyle/>
           <a:p>
-            <a:pPr indent="0" marL="0">
+            <a:pPr marL="0" indent="0">
               <a:buNone/>
             </a:pPr>
             <a:r>
@@ -7812,6 +7564,7 @@
         <a:solidFill>
           <a:srgbClr val="0B1220"/>
         </a:solidFill>
+        <a:effectLst/>
       </p:bgPr>
     </p:bg>
     <p:spTree>
@@ -7869,7 +7622,7 @@
           <a:bodyPr wrap="square" rtlCol="0" anchor="ctr"/>
           <a:lstStyle/>
           <a:p>
-            <a:pPr indent="0" marL="0">
+            <a:pPr marL="0" indent="0">
               <a:buNone/>
             </a:pPr>
             <a:r>
@@ -7908,7 +7661,7 @@
           <a:bodyPr wrap="square" rtlCol="0" anchor="ctr"/>
           <a:lstStyle/>
           <a:p>
-            <a:pPr indent="0" marL="0">
+            <a:pPr marL="0" indent="0">
               <a:buNone/>
             </a:pPr>
             <a:r>
@@ -7967,7 +7720,7 @@
           <a:bodyPr wrap="square" rtlCol="0" anchor="ctr"/>
           <a:lstStyle/>
           <a:p>
-            <a:pPr indent="0" marL="0">
+            <a:pPr marL="0" indent="0">
               <a:buNone/>
             </a:pPr>
             <a:r>
@@ -8033,7 +7786,7 @@
           <a:bodyPr wrap="square" rtlCol="0" anchor="ctr"/>
           <a:lstStyle/>
           <a:p>
-            <a:pPr indent="0" marL="0">
+            <a:pPr marL="0" indent="0">
               <a:buNone/>
             </a:pPr>
             <a:r>
@@ -8205,7 +7958,7 @@
           <a:bodyPr wrap="square" rtlCol="0" anchor="ctr"/>
           <a:lstStyle/>
           <a:p>
-            <a:pPr indent="0" marL="0">
+            <a:pPr marL="0" indent="0">
               <a:buNone/>
             </a:pPr>
             <a:r>
@@ -8345,6 +8098,7 @@
         <a:solidFill>
           <a:srgbClr val="0B1220"/>
         </a:solidFill>
+        <a:effectLst/>
       </p:bgPr>
     </p:bg>
     <p:spTree>
@@ -8402,7 +8156,7 @@
           <a:bodyPr wrap="square" rtlCol="0" anchor="ctr"/>
           <a:lstStyle/>
           <a:p>
-            <a:pPr indent="0" marL="0">
+            <a:pPr marL="0" indent="0">
               <a:buNone/>
             </a:pPr>
             <a:r>
@@ -8441,7 +8195,7 @@
           <a:bodyPr wrap="square" rtlCol="0" anchor="ctr"/>
           <a:lstStyle/>
           <a:p>
-            <a:pPr indent="0" marL="0">
+            <a:pPr marL="0" indent="0">
               <a:buNone/>
             </a:pPr>
             <a:r>
@@ -8500,7 +8254,7 @@
           <a:bodyPr wrap="square" rtlCol="0" anchor="ctr"/>
           <a:lstStyle/>
           <a:p>
-            <a:pPr indent="0" marL="0">
+            <a:pPr marL="0" indent="0">
               <a:buNone/>
             </a:pPr>
             <a:r>
@@ -8566,7 +8320,7 @@
           <a:bodyPr wrap="square" rtlCol="0" anchor="ctr"/>
           <a:lstStyle/>
           <a:p>
-            <a:pPr algn="ctr" indent="0" marL="0">
+            <a:pPr marL="0" indent="0" algn="ctr">
               <a:buNone/>
             </a:pPr>
             <a:r>
@@ -8605,7 +8359,7 @@
           <a:bodyPr wrap="square" rtlCol="0" anchor="ctr"/>
           <a:lstStyle/>
           <a:p>
-            <a:pPr algn="ctr" indent="0" marL="0">
+            <a:pPr marL="0" indent="0" algn="ctr">
               <a:buNone/>
             </a:pPr>
             <a:r>
@@ -8644,7 +8398,7 @@
           <a:bodyPr wrap="square" rtlCol="0" anchor="ctr"/>
           <a:lstStyle/>
           <a:p>
-            <a:pPr algn="ctr" indent="0" marL="0">
+            <a:pPr marL="0" indent="0" algn="ctr">
               <a:buNone/>
             </a:pPr>
             <a:r>
@@ -8710,7 +8464,7 @@
           <a:bodyPr wrap="square" rtlCol="0" anchor="ctr"/>
           <a:lstStyle/>
           <a:p>
-            <a:pPr algn="ctr" indent="0" marL="0">
+            <a:pPr marL="0" indent="0" algn="ctr">
               <a:buNone/>
             </a:pPr>
             <a:r>
@@ -8749,7 +8503,7 @@
           <a:bodyPr wrap="square" rtlCol="0" anchor="ctr"/>
           <a:lstStyle/>
           <a:p>
-            <a:pPr algn="ctr" indent="0" marL="0">
+            <a:pPr marL="0" indent="0" algn="ctr">
               <a:buNone/>
             </a:pPr>
             <a:r>
@@ -8788,7 +8542,7 @@
           <a:bodyPr wrap="square" rtlCol="0" anchor="ctr"/>
           <a:lstStyle/>
           <a:p>
-            <a:pPr algn="ctr" indent="0" marL="0">
+            <a:pPr marL="0" indent="0" algn="ctr">
               <a:buNone/>
             </a:pPr>
             <a:r>
@@ -8854,7 +8608,7 @@
           <a:bodyPr wrap="square" rtlCol="0" anchor="ctr"/>
           <a:lstStyle/>
           <a:p>
-            <a:pPr algn="ctr" indent="0" marL="0">
+            <a:pPr marL="0" indent="0" algn="ctr">
               <a:buNone/>
             </a:pPr>
             <a:r>
@@ -8893,7 +8647,7 @@
           <a:bodyPr wrap="square" rtlCol="0" anchor="ctr"/>
           <a:lstStyle/>
           <a:p>
-            <a:pPr algn="ctr" indent="0" marL="0">
+            <a:pPr marL="0" indent="0" algn="ctr">
               <a:buNone/>
             </a:pPr>
             <a:r>
@@ -8932,7 +8686,7 @@
           <a:bodyPr wrap="square" rtlCol="0" anchor="ctr"/>
           <a:lstStyle/>
           <a:p>
-            <a:pPr algn="ctr" indent="0" marL="0">
+            <a:pPr marL="0" indent="0" algn="ctr">
               <a:buNone/>
             </a:pPr>
             <a:r>
@@ -8998,7 +8752,7 @@
           <a:bodyPr wrap="square" rtlCol="0" anchor="ctr"/>
           <a:lstStyle/>
           <a:p>
-            <a:pPr algn="ctr" indent="0" marL="0">
+            <a:pPr marL="0" indent="0" algn="ctr">
               <a:buNone/>
             </a:pPr>
             <a:r>
@@ -9037,7 +8791,7 @@
           <a:bodyPr wrap="square" rtlCol="0" anchor="ctr"/>
           <a:lstStyle/>
           <a:p>
-            <a:pPr algn="ctr" indent="0" marL="0">
+            <a:pPr marL="0" indent="0" algn="ctr">
               <a:buNone/>
             </a:pPr>
             <a:r>
@@ -9076,7 +8830,7 @@
           <a:bodyPr wrap="square" rtlCol="0" anchor="ctr"/>
           <a:lstStyle/>
           <a:p>
-            <a:pPr algn="ctr" indent="0" marL="0">
+            <a:pPr marL="0" indent="0" algn="ctr">
               <a:buNone/>
             </a:pPr>
             <a:r>
@@ -9142,7 +8896,7 @@
           <a:bodyPr wrap="square" rtlCol="0" anchor="ctr"/>
           <a:lstStyle/>
           <a:p>
-            <a:pPr algn="ctr" indent="0" marL="0">
+            <a:pPr marL="0" indent="0" algn="ctr">
               <a:buNone/>
             </a:pPr>
             <a:r>
@@ -9181,7 +8935,7 @@
           <a:bodyPr wrap="square" rtlCol="0" anchor="ctr"/>
           <a:lstStyle/>
           <a:p>
-            <a:pPr algn="ctr" indent="0" marL="0">
+            <a:pPr marL="0" indent="0" algn="ctr">
               <a:buNone/>
             </a:pPr>
             <a:r>
@@ -9220,7 +8974,7 @@
           <a:bodyPr wrap="square" rtlCol="0" anchor="ctr"/>
           <a:lstStyle/>
           <a:p>
-            <a:pPr algn="ctr" indent="0" marL="0">
+            <a:pPr marL="0" indent="0" algn="ctr">
               <a:buNone/>
             </a:pPr>
             <a:r>
@@ -9286,7 +9040,7 @@
           <a:bodyPr wrap="square" rtlCol="0" anchor="ctr"/>
           <a:lstStyle/>
           <a:p>
-            <a:pPr algn="ctr" indent="0" marL="0">
+            <a:pPr marL="0" indent="0" algn="ctr">
               <a:buNone/>
             </a:pPr>
             <a:r>
@@ -9325,7 +9079,7 @@
           <a:bodyPr wrap="square" rtlCol="0" anchor="ctr"/>
           <a:lstStyle/>
           <a:p>
-            <a:pPr algn="ctr" indent="0" marL="0">
+            <a:pPr marL="0" indent="0" algn="ctr">
               <a:buNone/>
             </a:pPr>
             <a:r>
@@ -9411,11 +9165,11 @@
           <a:bodyPr wrap="square" rtlCol="0" anchor="ctr"/>
           <a:lstStyle/>
           <a:p>
-            <a:pPr indent="0" marL="0">
-              <a:buNone/>
-            </a:pPr>
-            <a:r>
-              <a:rPr lang="en-US" sz="2000" b="1" spc="300" kern="0" dirty="0">
+            <a:pPr marL="0" indent="0">
+              <a:buNone/>
+            </a:pPr>
+            <a:r>
+              <a:rPr lang="en-US" sz="2000" b="1" kern="0" spc="300" dirty="0">
                 <a:solidFill>
                   <a:srgbClr val="22D3EE"/>
                 </a:solidFill>
@@ -9450,7 +9204,7 @@
           <a:bodyPr wrap="square" rtlCol="0" anchor="ctr"/>
           <a:lstStyle/>
           <a:p>
-            <a:pPr indent="0" marL="0">
+            <a:pPr marL="0" indent="0">
               <a:buNone/>
             </a:pPr>
             <a:r>
@@ -9621,11 +9375,11 @@
           <a:bodyPr wrap="square" rtlCol="0" anchor="ctr"/>
           <a:lstStyle/>
           <a:p>
-            <a:pPr indent="0" marL="0">
-              <a:buNone/>
-            </a:pPr>
-            <a:r>
-              <a:rPr lang="en-US" sz="2000" b="1" spc="300" kern="0" dirty="0">
+            <a:pPr marL="0" indent="0">
+              <a:buNone/>
+            </a:pPr>
+            <a:r>
+              <a:rPr lang="en-US" sz="2000" b="1" kern="0" spc="300" dirty="0">
                 <a:solidFill>
                   <a:srgbClr val="A78BFA"/>
                 </a:solidFill>
@@ -9660,7 +9414,7 @@
           <a:bodyPr wrap="square" rtlCol="0" anchor="ctr"/>
           <a:lstStyle/>
           <a:p>
-            <a:pPr indent="0" marL="0">
+            <a:pPr marL="0" indent="0">
               <a:buNone/>
             </a:pPr>
             <a:r>
@@ -9831,11 +9585,11 @@
           <a:bodyPr wrap="square" rtlCol="0" anchor="ctr"/>
           <a:lstStyle/>
           <a:p>
-            <a:pPr indent="0" marL="0">
-              <a:buNone/>
-            </a:pPr>
-            <a:r>
-              <a:rPr lang="en-US" sz="2000" b="1" spc="300" kern="0" dirty="0">
+            <a:pPr marL="0" indent="0">
+              <a:buNone/>
+            </a:pPr>
+            <a:r>
+              <a:rPr lang="en-US" sz="2000" b="1" kern="0" spc="300" dirty="0">
                 <a:solidFill>
                   <a:srgbClr val="34D399"/>
                 </a:solidFill>
@@ -9870,7 +9624,7 @@
           <a:bodyPr wrap="square" rtlCol="0" anchor="ctr"/>
           <a:lstStyle/>
           <a:p>
-            <a:pPr indent="0" marL="0">
+            <a:pPr marL="0" indent="0">
               <a:buNone/>
             </a:pPr>
             <a:r>
@@ -9989,6 +9743,7 @@
         <a:solidFill>
           <a:srgbClr val="0B1220"/>
         </a:solidFill>
+        <a:effectLst/>
       </p:bgPr>
     </p:bg>
     <p:spTree>
@@ -10046,7 +9801,7 @@
           <a:bodyPr wrap="square" rtlCol="0" anchor="ctr"/>
           <a:lstStyle/>
           <a:p>
-            <a:pPr indent="0" marL="0">
+            <a:pPr marL="0" indent="0">
               <a:buNone/>
             </a:pPr>
             <a:r>
@@ -10085,7 +9840,7 @@
           <a:bodyPr wrap="square" rtlCol="0" anchor="ctr"/>
           <a:lstStyle/>
           <a:p>
-            <a:pPr indent="0" marL="0">
+            <a:pPr marL="0" indent="0">
               <a:buNone/>
             </a:pPr>
             <a:r>
@@ -10144,7 +9899,7 @@
           <a:bodyPr wrap="square" rtlCol="0" anchor="ctr"/>
           <a:lstStyle/>
           <a:p>
-            <a:pPr indent="0" marL="0">
+            <a:pPr marL="0" indent="0">
               <a:buNone/>
             </a:pPr>
             <a:r>
@@ -10230,7 +9985,7 @@
           <a:bodyPr wrap="square" rtlCol="0" anchor="ctr"/>
           <a:lstStyle/>
           <a:p>
-            <a:pPr indent="0" marL="0">
+            <a:pPr marL="0" indent="0">
               <a:buNone/>
             </a:pPr>
             <a:r>
@@ -10269,7 +10024,7 @@
           <a:bodyPr wrap="square" rtlCol="0" anchor="ctr"/>
           <a:lstStyle/>
           <a:p>
-            <a:pPr indent="0" marL="0">
+            <a:pPr marL="0" indent="0">
               <a:buNone/>
             </a:pPr>
             <a:r>
@@ -10355,7 +10110,7 @@
           <a:bodyPr wrap="square" rtlCol="0" anchor="ctr"/>
           <a:lstStyle/>
           <a:p>
-            <a:pPr indent="0" marL="0">
+            <a:pPr marL="0" indent="0">
               <a:buNone/>
             </a:pPr>
             <a:r>
@@ -10394,7 +10149,7 @@
           <a:bodyPr wrap="square" rtlCol="0" anchor="ctr"/>
           <a:lstStyle/>
           <a:p>
-            <a:pPr indent="0" marL="0">
+            <a:pPr marL="0" indent="0">
               <a:buNone/>
             </a:pPr>
             <a:r>
@@ -10480,7 +10235,7 @@
           <a:bodyPr wrap="square" rtlCol="0" anchor="ctr"/>
           <a:lstStyle/>
           <a:p>
-            <a:pPr indent="0" marL="0">
+            <a:pPr marL="0" indent="0">
               <a:buNone/>
             </a:pPr>
             <a:r>
@@ -10519,7 +10274,7 @@
           <a:bodyPr wrap="square" rtlCol="0" anchor="ctr"/>
           <a:lstStyle/>
           <a:p>
-            <a:pPr indent="0" marL="0">
+            <a:pPr marL="0" indent="0">
               <a:buNone/>
             </a:pPr>
             <a:r>
@@ -10605,7 +10360,7 @@
           <a:bodyPr wrap="square" rtlCol="0" anchor="ctr"/>
           <a:lstStyle/>
           <a:p>
-            <a:pPr indent="0" marL="0">
+            <a:pPr marL="0" indent="0">
               <a:buNone/>
             </a:pPr>
             <a:r>
@@ -10644,7 +10399,7 @@
           <a:bodyPr wrap="square" rtlCol="0" anchor="ctr"/>
           <a:lstStyle/>
           <a:p>
-            <a:pPr indent="0" marL="0">
+            <a:pPr marL="0" indent="0">
               <a:buNone/>
             </a:pPr>
             <a:r>
@@ -10730,7 +10485,7 @@
           <a:bodyPr wrap="square" rtlCol="0" anchor="ctr"/>
           <a:lstStyle/>
           <a:p>
-            <a:pPr indent="0" marL="0">
+            <a:pPr marL="0" indent="0">
               <a:buNone/>
             </a:pPr>
             <a:r>
@@ -10769,7 +10524,7 @@
           <a:bodyPr wrap="square" rtlCol="0" anchor="ctr"/>
           <a:lstStyle/>
           <a:p>
-            <a:pPr indent="0" marL="0">
+            <a:pPr marL="0" indent="0">
               <a:buNone/>
             </a:pPr>
             <a:r>
@@ -10855,7 +10610,7 @@
           <a:bodyPr wrap="square" rtlCol="0" anchor="ctr"/>
           <a:lstStyle/>
           <a:p>
-            <a:pPr indent="0" marL="0">
+            <a:pPr marL="0" indent="0">
               <a:buNone/>
             </a:pPr>
             <a:r>
@@ -10894,7 +10649,7 @@
           <a:bodyPr wrap="square" rtlCol="0" anchor="ctr"/>
           <a:lstStyle/>
           <a:p>
-            <a:pPr indent="0" marL="0">
+            <a:pPr marL="0" indent="0">
               <a:buNone/>
             </a:pPr>
             <a:r>
@@ -10980,7 +10735,7 @@
           <a:bodyPr wrap="square" rtlCol="0" anchor="ctr"/>
           <a:lstStyle/>
           <a:p>
-            <a:pPr indent="0" marL="0">
+            <a:pPr marL="0" indent="0">
               <a:buNone/>
             </a:pPr>
             <a:r>
@@ -11019,7 +10774,7 @@
           <a:bodyPr wrap="square" rtlCol="0" anchor="ctr"/>
           <a:lstStyle/>
           <a:p>
-            <a:pPr indent="0" marL="0">
+            <a:pPr marL="0" indent="0">
               <a:buNone/>
             </a:pPr>
             <a:r>
@@ -11105,7 +10860,7 @@
           <a:bodyPr wrap="square" rtlCol="0" anchor="ctr"/>
           <a:lstStyle/>
           <a:p>
-            <a:pPr indent="0" marL="0">
+            <a:pPr marL="0" indent="0">
               <a:buNone/>
             </a:pPr>
             <a:r>
@@ -11144,7 +10899,7 @@
           <a:bodyPr wrap="square" rtlCol="0" anchor="ctr"/>
           <a:lstStyle/>
           <a:p>
-            <a:pPr indent="0" marL="0">
+            <a:pPr marL="0" indent="0">
               <a:buNone/>
             </a:pPr>
             <a:r>
@@ -11230,7 +10985,7 @@
           <a:bodyPr wrap="square" rtlCol="0" anchor="ctr"/>
           <a:lstStyle/>
           <a:p>
-            <a:pPr indent="0" marL="0">
+            <a:pPr marL="0" indent="0">
               <a:buNone/>
             </a:pPr>
             <a:r>
@@ -11269,7 +11024,7 @@
           <a:bodyPr wrap="square" rtlCol="0" anchor="ctr"/>
           <a:lstStyle/>
           <a:p>
-            <a:pPr indent="0" marL="0">
+            <a:pPr marL="0" indent="0">
               <a:buNone/>
             </a:pPr>
             <a:r>
@@ -11355,7 +11110,7 @@
           <a:bodyPr wrap="square" rtlCol="0" anchor="ctr"/>
           <a:lstStyle/>
           <a:p>
-            <a:pPr indent="0" marL="0">
+            <a:pPr marL="0" indent="0">
               <a:buNone/>
             </a:pPr>
             <a:r>
@@ -11394,7 +11149,7 @@
           <a:bodyPr wrap="square" rtlCol="0" anchor="ctr"/>
           <a:lstStyle/>
           <a:p>
-            <a:pPr indent="0" marL="0">
+            <a:pPr marL="0" indent="0">
               <a:buNone/>
             </a:pPr>
             <a:r>
@@ -11428,6 +11183,7 @@
         <a:solidFill>
           <a:srgbClr val="0B1220"/>
         </a:solidFill>
+        <a:effectLst/>
       </p:bgPr>
     </p:bg>
     <p:spTree>
@@ -11485,7 +11241,7 @@
           <a:bodyPr wrap="square" rtlCol="0" anchor="ctr"/>
           <a:lstStyle/>
           <a:p>
-            <a:pPr indent="0" marL="0">
+            <a:pPr marL="0" indent="0">
               <a:buNone/>
             </a:pPr>
             <a:r>
@@ -11524,7 +11280,7 @@
           <a:bodyPr wrap="square" rtlCol="0" anchor="ctr"/>
           <a:lstStyle/>
           <a:p>
-            <a:pPr indent="0" marL="0">
+            <a:pPr marL="0" indent="0">
               <a:buNone/>
             </a:pPr>
             <a:r>
@@ -11583,7 +11339,7 @@
           <a:bodyPr wrap="square" rtlCol="0" anchor="ctr"/>
           <a:lstStyle/>
           <a:p>
-            <a:pPr indent="0" marL="0">
+            <a:pPr marL="0" indent="0">
               <a:buNone/>
             </a:pPr>
             <a:r>
@@ -11649,7 +11405,7 @@
           <a:bodyPr wrap="square" rtlCol="0" anchor="ctr"/>
           <a:lstStyle/>
           <a:p>
-            <a:pPr indent="0" marL="0">
+            <a:pPr marL="0" indent="0">
               <a:buNone/>
             </a:pPr>
             <a:r>
@@ -11688,7 +11444,7 @@
           <a:bodyPr wrap="square" rtlCol="0" anchor="ctr"/>
           <a:lstStyle/>
           <a:p>
-            <a:pPr indent="0" marL="0">
+            <a:pPr marL="0" indent="0">
               <a:buNone/>
             </a:pPr>
             <a:r>
@@ -11727,7 +11483,7 @@
           <a:bodyPr wrap="square" rtlCol="0" anchor="ctr"/>
           <a:lstStyle/>
           <a:p>
-            <a:pPr indent="0" marL="0">
+            <a:pPr marL="0" indent="0">
               <a:buNone/>
             </a:pPr>
             <a:r>
@@ -11793,7 +11549,7 @@
           <a:bodyPr wrap="square" rtlCol="0" anchor="ctr"/>
           <a:lstStyle/>
           <a:p>
-            <a:pPr indent="0" marL="0">
+            <a:pPr marL="0" indent="0">
               <a:buNone/>
             </a:pPr>
             <a:r>
@@ -11832,7 +11588,7 @@
           <a:bodyPr wrap="square" rtlCol="0" anchor="ctr"/>
           <a:lstStyle/>
           <a:p>
-            <a:pPr indent="0" marL="0">
+            <a:pPr marL="0" indent="0">
               <a:buNone/>
             </a:pPr>
             <a:r>
@@ -11871,7 +11627,7 @@
           <a:bodyPr wrap="square" rtlCol="0" anchor="ctr"/>
           <a:lstStyle/>
           <a:p>
-            <a:pPr indent="0" marL="0">
+            <a:pPr marL="0" indent="0">
               <a:buNone/>
             </a:pPr>
             <a:r>
@@ -11937,7 +11693,7 @@
           <a:bodyPr wrap="square" rtlCol="0" anchor="ctr"/>
           <a:lstStyle/>
           <a:p>
-            <a:pPr indent="0" marL="0">
+            <a:pPr marL="0" indent="0">
               <a:buNone/>
             </a:pPr>
             <a:r>
@@ -11976,7 +11732,7 @@
           <a:bodyPr wrap="square" rtlCol="0" anchor="ctr"/>
           <a:lstStyle/>
           <a:p>
-            <a:pPr indent="0" marL="0">
+            <a:pPr marL="0" indent="0">
               <a:buNone/>
             </a:pPr>
             <a:r>
@@ -12015,7 +11771,7 @@
           <a:bodyPr wrap="square" rtlCol="0" anchor="ctr"/>
           <a:lstStyle/>
           <a:p>
-            <a:pPr indent="0" marL="0">
+            <a:pPr marL="0" indent="0">
               <a:buNone/>
             </a:pPr>
             <a:r>
@@ -12081,7 +11837,7 @@
           <a:bodyPr wrap="square" rtlCol="0" anchor="ctr"/>
           <a:lstStyle/>
           <a:p>
-            <a:pPr indent="0" marL="0">
+            <a:pPr marL="0" indent="0">
               <a:buNone/>
             </a:pPr>
             <a:r>
@@ -12120,7 +11876,7 @@
           <a:bodyPr wrap="square" rtlCol="0" anchor="ctr"/>
           <a:lstStyle/>
           <a:p>
-            <a:pPr indent="0" marL="0">
+            <a:pPr marL="0" indent="0">
               <a:buNone/>
             </a:pPr>
             <a:r>
@@ -12159,7 +11915,7 @@
           <a:bodyPr wrap="square" rtlCol="0" anchor="ctr"/>
           <a:lstStyle/>
           <a:p>
-            <a:pPr indent="0" marL="0">
+            <a:pPr marL="0" indent="0">
               <a:buNone/>
             </a:pPr>
             <a:r>
@@ -12225,7 +11981,7 @@
           <a:bodyPr wrap="square" rtlCol="0" anchor="ctr"/>
           <a:lstStyle/>
           <a:p>
-            <a:pPr indent="0" marL="0">
+            <a:pPr marL="0" indent="0">
               <a:buNone/>
             </a:pPr>
             <a:r>
@@ -12264,7 +12020,7 @@
           <a:bodyPr wrap="square" rtlCol="0" anchor="ctr"/>
           <a:lstStyle/>
           <a:p>
-            <a:pPr indent="0" marL="0">
+            <a:pPr marL="0" indent="0">
               <a:buNone/>
             </a:pPr>
             <a:r>
@@ -12303,7 +12059,7 @@
           <a:bodyPr wrap="square" rtlCol="0" anchor="ctr"/>
           <a:lstStyle/>
           <a:p>
-            <a:pPr indent="0" marL="0">
+            <a:pPr marL="0" indent="0">
               <a:buNone/>
             </a:pPr>
             <a:r>
@@ -12337,6 +12093,7 @@
         <a:solidFill>
           <a:srgbClr val="0B1220"/>
         </a:solidFill>
+        <a:effectLst/>
       </p:bgPr>
     </p:bg>
     <p:spTree>
@@ -12394,7 +12151,7 @@
           <a:bodyPr wrap="square" rtlCol="0" anchor="ctr"/>
           <a:lstStyle/>
           <a:p>
-            <a:pPr indent="0" marL="0">
+            <a:pPr marL="0" indent="0">
               <a:buNone/>
             </a:pPr>
             <a:r>
@@ -12433,7 +12190,7 @@
           <a:bodyPr wrap="square" rtlCol="0" anchor="ctr"/>
           <a:lstStyle/>
           <a:p>
-            <a:pPr indent="0" marL="0">
+            <a:pPr marL="0" indent="0">
               <a:buNone/>
             </a:pPr>
             <a:r>
@@ -12492,7 +12249,7 @@
           <a:bodyPr wrap="square" rtlCol="0" anchor="ctr"/>
           <a:lstStyle/>
           <a:p>
-            <a:pPr indent="0" marL="0">
+            <a:pPr marL="0" indent="0">
               <a:buNone/>
             </a:pPr>
             <a:r>
@@ -12578,7 +12335,7 @@
           <a:bodyPr wrap="square" rtlCol="0" anchor="ctr"/>
           <a:lstStyle/>
           <a:p>
-            <a:pPr indent="0" marL="0">
+            <a:pPr marL="0" indent="0">
               <a:buNone/>
             </a:pPr>
             <a:r>
@@ -12617,7 +12374,7 @@
           <a:bodyPr wrap="square" rtlCol="0" anchor="ctr"/>
           <a:lstStyle/>
           <a:p>
-            <a:pPr algn="r" indent="0" marL="0">
+            <a:pPr marL="0" indent="0" algn="r">
               <a:buNone/>
             </a:pPr>
             <a:r>
@@ -12656,7 +12413,7 @@
           <a:bodyPr wrap="square" rtlCol="0" anchor="ctr"/>
           <a:lstStyle/>
           <a:p>
-            <a:pPr indent="0" marL="0">
+            <a:pPr marL="0" indent="0">
               <a:buNone/>
             </a:pPr>
             <a:r>
@@ -12742,7 +12499,7 @@
           <a:bodyPr wrap="square" rtlCol="0" anchor="ctr"/>
           <a:lstStyle/>
           <a:p>
-            <a:pPr indent="0" marL="0">
+            <a:pPr marL="0" indent="0">
               <a:buNone/>
             </a:pPr>
             <a:r>
@@ -12781,7 +12538,7 @@
           <a:bodyPr wrap="square" rtlCol="0" anchor="ctr"/>
           <a:lstStyle/>
           <a:p>
-            <a:pPr algn="r" indent="0" marL="0">
+            <a:pPr marL="0" indent="0" algn="r">
               <a:buNone/>
             </a:pPr>
             <a:r>
@@ -12820,7 +12577,7 @@
           <a:bodyPr wrap="square" rtlCol="0" anchor="ctr"/>
           <a:lstStyle/>
           <a:p>
-            <a:pPr indent="0" marL="0">
+            <a:pPr marL="0" indent="0">
               <a:buNone/>
             </a:pPr>
             <a:r>
@@ -12906,7 +12663,7 @@
           <a:bodyPr wrap="square" rtlCol="0" anchor="ctr"/>
           <a:lstStyle/>
           <a:p>
-            <a:pPr indent="0" marL="0">
+            <a:pPr marL="0" indent="0">
               <a:buNone/>
             </a:pPr>
             <a:r>
@@ -12945,7 +12702,7 @@
           <a:bodyPr wrap="square" rtlCol="0" anchor="ctr"/>
           <a:lstStyle/>
           <a:p>
-            <a:pPr algn="r" indent="0" marL="0">
+            <a:pPr marL="0" indent="0" algn="r">
               <a:buNone/>
             </a:pPr>
             <a:r>
@@ -12984,7 +12741,7 @@
           <a:bodyPr wrap="square" rtlCol="0" anchor="ctr"/>
           <a:lstStyle/>
           <a:p>
-            <a:pPr indent="0" marL="0">
+            <a:pPr marL="0" indent="0">
               <a:buNone/>
             </a:pPr>
             <a:r>
@@ -13018,6 +12775,7 @@
         <a:solidFill>
           <a:srgbClr val="0B1220"/>
         </a:solidFill>
+        <a:effectLst/>
       </p:bgPr>
     </p:bg>
     <p:spTree>
@@ -13075,7 +12833,7 @@
           <a:bodyPr wrap="square" rtlCol="0" anchor="ctr"/>
           <a:lstStyle/>
           <a:p>
-            <a:pPr indent="0" marL="0">
+            <a:pPr marL="0" indent="0">
               <a:buNone/>
             </a:pPr>
             <a:r>
@@ -13114,7 +12872,7 @@
           <a:bodyPr wrap="square" rtlCol="0" anchor="ctr"/>
           <a:lstStyle/>
           <a:p>
-            <a:pPr algn="r" indent="0" marL="0">
+            <a:pPr marL="0" indent="0" algn="r">
               <a:buNone/>
             </a:pPr>
             <a:r>
@@ -13153,7 +12911,7 @@
           <a:bodyPr wrap="square" rtlCol="0" anchor="ctr"/>
           <a:lstStyle/>
           <a:p>
-            <a:pPr indent="0" marL="0">
+            <a:pPr marL="0" indent="0">
               <a:buNone/>
             </a:pPr>
             <a:r>
@@ -13212,7 +12970,7 @@
           <a:bodyPr wrap="square" rtlCol="0" anchor="ctr"/>
           <a:lstStyle/>
           <a:p>
-            <a:pPr indent="0" marL="0">
+            <a:pPr marL="0" indent="0">
               <a:buNone/>
             </a:pPr>
             <a:r>
@@ -13278,7 +13036,7 @@
           <a:bodyPr wrap="square" rtlCol="0" anchor="ctr"/>
           <a:lstStyle/>
           <a:p>
-            <a:pPr indent="0" marL="0">
+            <a:pPr marL="0" indent="0">
               <a:buNone/>
             </a:pPr>
             <a:r>
@@ -13555,7 +13313,7 @@
           <a:bodyPr wrap="square" rtlCol="0" anchor="ctr"/>
           <a:lstStyle/>
           <a:p>
-            <a:pPr indent="0" marL="0">
+            <a:pPr marL="0" indent="0">
               <a:buNone/>
             </a:pPr>
             <a:r>
@@ -13706,7 +13464,7 @@
           <a:bodyPr wrap="square" rtlCol="0" anchor="ctr"/>
           <a:lstStyle/>
           <a:p>
-            <a:pPr indent="0" marL="0">
+            <a:pPr marL="0" indent="0">
               <a:buNone/>
             </a:pPr>
             <a:r>
@@ -13825,6 +13583,7 @@
         <a:solidFill>
           <a:srgbClr val="0B1220"/>
         </a:solidFill>
+        <a:effectLst/>
       </p:bgPr>
     </p:bg>
     <p:spTree>
@@ -13882,7 +13641,7 @@
           <a:bodyPr wrap="square" rtlCol="0" anchor="ctr"/>
           <a:lstStyle/>
           <a:p>
-            <a:pPr indent="0" marL="0">
+            <a:pPr marL="0" indent="0">
               <a:buNone/>
             </a:pPr>
             <a:r>
@@ -13921,7 +13680,7 @@
           <a:bodyPr wrap="square" rtlCol="0" anchor="ctr"/>
           <a:lstStyle/>
           <a:p>
-            <a:pPr algn="r" indent="0" marL="0">
+            <a:pPr marL="0" indent="0" algn="r">
               <a:buNone/>
             </a:pPr>
             <a:r>
@@ -13960,7 +13719,7 @@
           <a:bodyPr wrap="square" rtlCol="0" anchor="ctr"/>
           <a:lstStyle/>
           <a:p>
-            <a:pPr indent="0" marL="0">
+            <a:pPr marL="0" indent="0">
               <a:buNone/>
             </a:pPr>
             <a:r>
@@ -14019,7 +13778,7 @@
           <a:bodyPr wrap="square" rtlCol="0" anchor="ctr"/>
           <a:lstStyle/>
           <a:p>
-            <a:pPr indent="0" marL="0">
+            <a:pPr marL="0" indent="0">
               <a:buNone/>
             </a:pPr>
             <a:r>
@@ -14085,7 +13844,7 @@
           <a:bodyPr wrap="square" rtlCol="0" anchor="ctr"/>
           <a:lstStyle/>
           <a:p>
-            <a:pPr indent="0" marL="0">
+            <a:pPr marL="0" indent="0">
               <a:buNone/>
             </a:pPr>
             <a:r>
@@ -14320,7 +14079,7 @@
           <a:bodyPr wrap="square" rtlCol="0" anchor="ctr"/>
           <a:lstStyle/>
           <a:p>
-            <a:pPr indent="0" marL="0">
+            <a:pPr marL="0" indent="0">
               <a:buNone/>
             </a:pPr>
             <a:r>
@@ -14450,7 +14209,7 @@
           <a:bodyPr wrap="square" rtlCol="0" anchor="ctr"/>
           <a:lstStyle/>
           <a:p>
-            <a:pPr indent="0" marL="0">
+            <a:pPr marL="0" indent="0">
               <a:buNone/>
             </a:pPr>
             <a:r>
@@ -14854,4 +14613,265 @@
     </a:ext>
   </a:extLst>
 </a:theme>
+</file>
+
+<file path=ppt/theme/theme2.xml><?xml version="1.0" encoding="utf-8"?>
+<a:theme xmlns:a="http://schemas.openxmlformats.org/drawingml/2006/main" name="Office Theme">
+  <a:themeElements>
+    <a:clrScheme name="Office">
+      <a:dk1>
+        <a:sysClr val="windowText" lastClr="000000"/>
+      </a:dk1>
+      <a:lt1>
+        <a:sysClr val="window" lastClr="FFFFFF"/>
+      </a:lt1>
+      <a:dk2>
+        <a:srgbClr val="44546A"/>
+      </a:dk2>
+      <a:lt2>
+        <a:srgbClr val="E7E6E6"/>
+      </a:lt2>
+      <a:accent1>
+        <a:srgbClr val="5B9BD5"/>
+      </a:accent1>
+      <a:accent2>
+        <a:srgbClr val="ED7D31"/>
+      </a:accent2>
+      <a:accent3>
+        <a:srgbClr val="A5A5A5"/>
+      </a:accent3>
+      <a:accent4>
+        <a:srgbClr val="FFC000"/>
+      </a:accent4>
+      <a:accent5>
+        <a:srgbClr val="4472C4"/>
+      </a:accent5>
+      <a:accent6>
+        <a:srgbClr val="70AD47"/>
+      </a:accent6>
+      <a:hlink>
+        <a:srgbClr val="0563C1"/>
+      </a:hlink>
+      <a:folHlink>
+        <a:srgbClr val="954F72"/>
+      </a:folHlink>
+    </a:clrScheme>
+    <a:fontScheme name="Office">
+      <a:majorFont>
+        <a:latin typeface="Calibri Light" panose="020F0302020204030204"/>
+        <a:ea typeface=""/>
+        <a:cs typeface=""/>
+        <a:font script="Jpan" typeface="ＭＳ Ｐゴシック"/>
+        <a:font script="Hang" typeface="맑은 고딕"/>
+        <a:font script="Hans" typeface="宋体"/>
+        <a:font script="Hant" typeface="新細明體"/>
+        <a:font script="Arab" typeface="Times New Roman"/>
+        <a:font script="Hebr" typeface="Times New Roman"/>
+        <a:font script="Thai" typeface="Angsana New"/>
+        <a:font script="Ethi" typeface="Nyala"/>
+        <a:font script="Beng" typeface="Vrinda"/>
+        <a:font script="Gujr" typeface="Shruti"/>
+        <a:font script="Khmr" typeface="MoolBoran"/>
+        <a:font script="Knda" typeface="Tunga"/>
+        <a:font script="Guru" typeface="Raavi"/>
+        <a:font script="Cans" typeface="Euphemia"/>
+        <a:font script="Cher" typeface="Plantagenet Cherokee"/>
+        <a:font script="Yiii" typeface="Microsoft Yi Baiti"/>
+        <a:font script="Tibt" typeface="Microsoft Himalaya"/>
+        <a:font script="Thaa" typeface="MV Boli"/>
+        <a:font script="Deva" typeface="Mangal"/>
+        <a:font script="Telu" typeface="Gautami"/>
+        <a:font script="Taml" typeface="Latha"/>
+        <a:font script="Syrc" typeface="Estrangelo Edessa"/>
+        <a:font script="Orya" typeface="Kalinga"/>
+        <a:font script="Mlym" typeface="Kartika"/>
+        <a:font script="Laoo" typeface="DokChampa"/>
+        <a:font script="Sinh" typeface="Iskoola Pota"/>
+        <a:font script="Mong" typeface="Mongolian Baiti"/>
+        <a:font script="Viet" typeface="Times New Roman"/>
+        <a:font script="Uigh" typeface="Microsoft Uighur"/>
+        <a:font script="Geor" typeface="Sylfaen"/>
+      </a:majorFont>
+      <a:minorFont>
+        <a:latin typeface="Calibri" panose="020F0502020204030204"/>
+        <a:ea typeface=""/>
+        <a:cs typeface=""/>
+        <a:font script="Jpan" typeface="ＭＳ Ｐゴシック"/>
+        <a:font script="Hang" typeface="맑은 고딕"/>
+        <a:font script="Hans" typeface="宋体"/>
+        <a:font script="Hant" typeface="新細明體"/>
+        <a:font script="Arab" typeface="Arial"/>
+        <a:font script="Hebr" typeface="Arial"/>
+        <a:font script="Thai" typeface="Cordia New"/>
+        <a:font script="Ethi" typeface="Nyala"/>
+        <a:font script="Beng" typeface="Vrinda"/>
+        <a:font script="Gujr" typeface="Shruti"/>
+        <a:font script="Khmr" typeface="DaunPenh"/>
+        <a:font script="Knda" typeface="Tunga"/>
+        <a:font script="Guru" typeface="Raavi"/>
+        <a:font script="Cans" typeface="Euphemia"/>
+        <a:font script="Cher" typeface="Plantagenet Cherokee"/>
+        <a:font script="Yiii" typeface="Microsoft Yi Baiti"/>
+        <a:font script="Tibt" typeface="Microsoft Himalaya"/>
+        <a:font script="Thaa" typeface="MV Boli"/>
+        <a:font script="Deva" typeface="Mangal"/>
+        <a:font script="Telu" typeface="Gautami"/>
+        <a:font script="Taml" typeface="Latha"/>
+        <a:font script="Syrc" typeface="Estrangelo Edessa"/>
+        <a:font script="Orya" typeface="Kalinga"/>
+        <a:font script="Mlym" typeface="Kartika"/>
+        <a:font script="Laoo" typeface="DokChampa"/>
+        <a:font script="Sinh" typeface="Iskoola Pota"/>
+        <a:font script="Mong" typeface="Mongolian Baiti"/>
+        <a:font script="Viet" typeface="Arial"/>
+        <a:font script="Uigh" typeface="Microsoft Uighur"/>
+        <a:font script="Geor" typeface="Sylfaen"/>
+      </a:minorFont>
+    </a:fontScheme>
+    <a:fmtScheme name="Office">
+      <a:fillStyleLst>
+        <a:solidFill>
+          <a:schemeClr val="phClr"/>
+        </a:solidFill>
+        <a:gradFill rotWithShape="1">
+          <a:gsLst>
+            <a:gs pos="0">
+              <a:schemeClr val="phClr">
+                <a:lumMod val="110000"/>
+                <a:satMod val="105000"/>
+                <a:tint val="67000"/>
+              </a:schemeClr>
+            </a:gs>
+            <a:gs pos="50000">
+              <a:schemeClr val="phClr">
+                <a:lumMod val="105000"/>
+                <a:satMod val="103000"/>
+                <a:tint val="73000"/>
+              </a:schemeClr>
+            </a:gs>
+            <a:gs pos="100000">
+              <a:schemeClr val="phClr">
+                <a:lumMod val="105000"/>
+                <a:satMod val="109000"/>
+                <a:tint val="81000"/>
+              </a:schemeClr>
+            </a:gs>
+          </a:gsLst>
+          <a:lin ang="5400000" scaled="0"/>
+        </a:gradFill>
+        <a:gradFill rotWithShape="1">
+          <a:gsLst>
+            <a:gs pos="0">
+              <a:schemeClr val="phClr">
+                <a:satMod val="103000"/>
+                <a:lumMod val="102000"/>
+                <a:tint val="94000"/>
+              </a:schemeClr>
+            </a:gs>
+            <a:gs pos="50000">
+              <a:schemeClr val="phClr">
+                <a:satMod val="110000"/>
+                <a:lumMod val="100000"/>
+                <a:shade val="100000"/>
+              </a:schemeClr>
+            </a:gs>
+            <a:gs pos="100000">
+              <a:schemeClr val="phClr">
+                <a:lumMod val="99000"/>
+                <a:satMod val="120000"/>
+                <a:shade val="78000"/>
+              </a:schemeClr>
+            </a:gs>
+          </a:gsLst>
+          <a:lin ang="5400000" scaled="0"/>
+        </a:gradFill>
+      </a:fillStyleLst>
+      <a:lnStyleLst>
+        <a:ln w="6350" cap="flat" cmpd="sng" algn="ctr">
+          <a:solidFill>
+            <a:schemeClr val="phClr"/>
+          </a:solidFill>
+          <a:prstDash val="solid"/>
+          <a:miter lim="800000"/>
+        </a:ln>
+        <a:ln w="12700" cap="flat" cmpd="sng" algn="ctr">
+          <a:solidFill>
+            <a:schemeClr val="phClr"/>
+          </a:solidFill>
+          <a:prstDash val="solid"/>
+          <a:miter lim="800000"/>
+        </a:ln>
+        <a:ln w="19050" cap="flat" cmpd="sng" algn="ctr">
+          <a:solidFill>
+            <a:schemeClr val="phClr"/>
+          </a:solidFill>
+          <a:prstDash val="solid"/>
+          <a:miter lim="800000"/>
+        </a:ln>
+      </a:lnStyleLst>
+      <a:effectStyleLst>
+        <a:effectStyle>
+          <a:effectLst/>
+        </a:effectStyle>
+        <a:effectStyle>
+          <a:effectLst/>
+        </a:effectStyle>
+        <a:effectStyle>
+          <a:effectLst>
+            <a:outerShdw blurRad="57150" dist="19050" dir="5400000" algn="ctr" rotWithShape="0">
+              <a:srgbClr val="000000">
+                <a:alpha val="63000"/>
+              </a:srgbClr>
+            </a:outerShdw>
+          </a:effectLst>
+        </a:effectStyle>
+      </a:effectStyleLst>
+      <a:bgFillStyleLst>
+        <a:solidFill>
+          <a:schemeClr val="phClr"/>
+        </a:solidFill>
+        <a:solidFill>
+          <a:schemeClr val="phClr">
+            <a:tint val="95000"/>
+            <a:satMod val="170000"/>
+          </a:schemeClr>
+        </a:solidFill>
+        <a:gradFill rotWithShape="1">
+          <a:gsLst>
+            <a:gs pos="0">
+              <a:schemeClr val="phClr">
+                <a:tint val="93000"/>
+                <a:satMod val="150000"/>
+                <a:shade val="98000"/>
+                <a:lumMod val="102000"/>
+              </a:schemeClr>
+            </a:gs>
+            <a:gs pos="50000">
+              <a:schemeClr val="phClr">
+                <a:tint val="98000"/>
+                <a:satMod val="130000"/>
+                <a:shade val="90000"/>
+                <a:lumMod val="103000"/>
+              </a:schemeClr>
+            </a:gs>
+            <a:gs pos="100000">
+              <a:schemeClr val="phClr">
+                <a:shade val="63000"/>
+                <a:satMod val="120000"/>
+              </a:schemeClr>
+            </a:gs>
+          </a:gsLst>
+          <a:lin ang="5400000" scaled="0"/>
+        </a:gradFill>
+      </a:bgFillStyleLst>
+    </a:fmtScheme>
+  </a:themeElements>
+  <a:objectDefaults/>
+  <a:extraClrSchemeLst/>
+  <a:extLst>
+    <a:ext uri="{05A4C25C-085E-4340-85A3-A5531E510DB2}">
+      <thm15:themeFamily xmlns:thm15="http://schemas.microsoft.com/office/thememl/2012/main" name="Office Theme" id="{62F939B6-93AF-4DB8-9C6B-D6C7DFDC589F}" vid="{4A3C46E8-61CC-4603-A589-7422A47A8E4A}"/>
+    </a:ext>
+  </a:extLst>
+</a:theme>
 </file>
</xml_diff>